<commit_message>
docs: deck as an editable PPTX - real text boxes and shapes
Replaces the picture-per-slide export. Geometry, colours and font sizes are
read off the rendered page rather than retyped, so the layout matches the deck
and every string is editable in PowerPoint.

Three things that had to be got right: a heading and its <em> are one box with
two runs (capturing both doubled every title), single-line labels are widened
and told not to wrap (PowerPoint's metrics are not the browser's), and the
glyph pass makes text transparent rather than removing it - deleting it
collapsed the flex layout and moved every logo.

Brand marks stay as one transparent overlay image per slide: they are inline
SVG paths with nothing to edit. Also gitignores local recordings - a git add -A
swept two multi-hundred-megabyte takes into a commit GitHub refused.
</commit_message>
<xml_diff>
--- a/docs/gavel-architecture.pptx
+++ b/docs/gavel-architecture.pptx
@@ -574,7 +574,7 @@
           <a:lstStyle/>
           <a:p>
             <a:r>
-              <a:t>Built and checked by machines too. Devin wrote PRs, Quality Clouds scanned the repo, Galtea scored the chair across five dimensions, Langfuse traced every model call.</a:t>
+              <a:t>Built and checked by machines too. Devin wrote PRs, Quality Clouds scanned the repo, Galtea scored the chair, Langfuse traced every model call.</a:t>
             </a:r>
           </a:p>
         </p:txBody>
@@ -644,7 +644,7 @@
           <a:lstStyle/>
           <a:p>
             <a:r>
-              <a:t>Discord was the demo. Teams is the product. One container knows what a voice call is. Company rules set once and enforced everywhere, and a hand-off plugin that pushes the transcript, decisions and open items into the team's own knowledge agent.</a:t>
+              <a:t>Discord was the demo. Teams is the product. Company rules set once, and a hand-off plugin that pushes the transcript, decisions and open items into the team's own agent.</a:t>
             </a:r>
           </a:p>
         </p:txBody>
@@ -3643,6 +3643,14 @@
 <file path=ppt/slides/slide1.xml><?xml version="1.0" encoding="utf-8"?>
 <p:sld xmlns:a="http://schemas.openxmlformats.org/drawingml/2006/main" xmlns:p="http://schemas.openxmlformats.org/presentationml/2006/main" xmlns:r="http://schemas.openxmlformats.org/officeDocument/2006/relationships">
   <p:cSld>
+    <p:bg>
+      <p:bgPr>
+        <a:solidFill>
+          <a:srgbClr val="FBFBFD"/>
+        </a:solidFill>
+        <a:effectLst/>
+      </p:bgPr>
+    </p:bg>
     <p:spTree>
       <p:nvGrpSpPr>
         <p:cNvPr id="1" name=""/>
@@ -3650,9 +3658,153 @@
         <p:nvPr/>
       </p:nvGrpSpPr>
       <p:grpSpPr/>
+      <p:sp>
+        <p:nvSpPr>
+          <p:cNvPr id="2" name="Rounded Rectangle 1"/>
+          <p:cNvSpPr/>
+          <p:nvPr/>
+        </p:nvSpPr>
+        <p:spPr>
+          <a:xfrm>
+            <a:off x="1727200" y="1324967"/>
+            <a:ext cx="3031132" cy="4600475"/>
+          </a:xfrm>
+          <a:prstGeom prst="roundRect">
+            <a:avLst>
+              <a:gd name="adj" fmla="val 4189"/>
+            </a:avLst>
+          </a:prstGeom>
+          <a:solidFill>
+            <a:srgbClr val="FFFFFF"/>
+          </a:solidFill>
+          <a:ln w="9525">
+            <a:solidFill>
+              <a:srgbClr val="E4E4EA"/>
+            </a:solidFill>
+          </a:ln>
+          <a:effectLst/>
+        </p:spPr>
+        <p:style>
+          <a:lnRef idx="1">
+            <a:schemeClr val="accent1"/>
+          </a:lnRef>
+          <a:fillRef idx="3">
+            <a:schemeClr val="accent1"/>
+          </a:fillRef>
+          <a:effectRef idx="2">
+            <a:schemeClr val="accent1"/>
+          </a:effectRef>
+          <a:fontRef idx="minor">
+            <a:schemeClr val="lt1"/>
+          </a:fontRef>
+        </p:style>
+        <p:txBody>
+          <a:bodyPr rtlCol="0" anchor="ctr"/>
+          <a:lstStyle/>
+          <a:p>
+            <a:pPr algn="ctr"/>
+          </a:p>
+        </p:txBody>
+      </p:sp>
+      <p:sp>
+        <p:nvSpPr>
+          <p:cNvPr id="3" name="Rounded Rectangle 2"/>
+          <p:cNvSpPr/>
+          <p:nvPr/>
+        </p:nvSpPr>
+        <p:spPr>
+          <a:xfrm>
+            <a:off x="5221783" y="1324967"/>
+            <a:ext cx="3031132" cy="4600475"/>
+          </a:xfrm>
+          <a:prstGeom prst="roundRect">
+            <a:avLst>
+              <a:gd name="adj" fmla="val 4189"/>
+            </a:avLst>
+          </a:prstGeom>
+          <a:solidFill>
+            <a:srgbClr val="FFFFFF"/>
+          </a:solidFill>
+          <a:ln w="9525">
+            <a:solidFill>
+              <a:srgbClr val="E4E4EA"/>
+            </a:solidFill>
+          </a:ln>
+          <a:effectLst/>
+        </p:spPr>
+        <p:style>
+          <a:lnRef idx="1">
+            <a:schemeClr val="accent1"/>
+          </a:lnRef>
+          <a:fillRef idx="3">
+            <a:schemeClr val="accent1"/>
+          </a:fillRef>
+          <a:effectRef idx="2">
+            <a:schemeClr val="accent1"/>
+          </a:effectRef>
+          <a:fontRef idx="minor">
+            <a:schemeClr val="lt1"/>
+          </a:fontRef>
+        </p:style>
+        <p:txBody>
+          <a:bodyPr rtlCol="0" anchor="ctr"/>
+          <a:lstStyle/>
+          <a:p>
+            <a:pPr algn="ctr"/>
+          </a:p>
+        </p:txBody>
+      </p:sp>
+      <p:sp>
+        <p:nvSpPr>
+          <p:cNvPr id="4" name="Rounded Rectangle 3"/>
+          <p:cNvSpPr/>
+          <p:nvPr/>
+        </p:nvSpPr>
+        <p:spPr>
+          <a:xfrm>
+            <a:off x="8716367" y="1324967"/>
+            <a:ext cx="3031132" cy="4600475"/>
+          </a:xfrm>
+          <a:prstGeom prst="roundRect">
+            <a:avLst>
+              <a:gd name="adj" fmla="val 4189"/>
+            </a:avLst>
+          </a:prstGeom>
+          <a:solidFill>
+            <a:srgbClr val="FFFFFF"/>
+          </a:solidFill>
+          <a:ln w="9525">
+            <a:solidFill>
+              <a:srgbClr val="E4E4EA"/>
+            </a:solidFill>
+          </a:ln>
+          <a:effectLst/>
+        </p:spPr>
+        <p:style>
+          <a:lnRef idx="1">
+            <a:schemeClr val="accent1"/>
+          </a:lnRef>
+          <a:fillRef idx="3">
+            <a:schemeClr val="accent1"/>
+          </a:fillRef>
+          <a:effectRef idx="2">
+            <a:schemeClr val="accent1"/>
+          </a:effectRef>
+          <a:fontRef idx="minor">
+            <a:schemeClr val="lt1"/>
+          </a:fontRef>
+        </p:style>
+        <p:txBody>
+          <a:bodyPr rtlCol="0" anchor="ctr"/>
+          <a:lstStyle/>
+          <a:p>
+            <a:pPr algn="ctr"/>
+          </a:p>
+        </p:txBody>
+      </p:sp>
       <p:pic>
         <p:nvPicPr>
-          <p:cNvPr id="2" name="Picture 1" descr="deck-1.png"/>
+          <p:cNvPr id="5" name="Picture 4" descr="deck-glyphs-1.png"/>
           <p:cNvPicPr>
             <a:picLocks noChangeAspect="1"/>
           </p:cNvPicPr>
@@ -3674,6 +3826,1194 @@
           </a:prstGeom>
         </p:spPr>
       </p:pic>
+      <p:sp>
+        <p:nvSpPr>
+          <p:cNvPr id="6" name="TextBox 5"/>
+          <p:cNvSpPr txBox="1"/>
+          <p:nvPr/>
+        </p:nvSpPr>
+        <p:spPr>
+          <a:xfrm>
+            <a:off x="444500" y="288032"/>
+            <a:ext cx="11493500" cy="195579"/>
+          </a:xfrm>
+          <a:prstGeom prst="rect">
+            <a:avLst/>
+          </a:prstGeom>
+          <a:noFill/>
+        </p:spPr>
+        <p:txBody>
+          <a:bodyPr wrap="none" lIns="0" rIns="0" tIns="0" bIns="0" anchor="t">
+            <a:spAutoFit/>
+          </a:bodyPr>
+          <a:lstStyle/>
+          <a:p>
+            <a:pPr algn="l">
+              <a:lnSpc>
+                <a:spcPct val="150000"/>
+              </a:lnSpc>
+            </a:pPr>
+            <a:r>
+              <a:rPr sz="980" b="0" spc="308">
+                <a:solidFill>
+                  <a:srgbClr val="6E6E73"/>
+                </a:solidFill>
+                <a:latin typeface="Helvetica Neue"/>
+              </a:rPr>
+              <a:t>GAVEL</a:t>
+            </a:r>
+          </a:p>
+        </p:txBody>
+      </p:sp>
+      <p:sp>
+        <p:nvSpPr>
+          <p:cNvPr id="7" name="TextBox 6"/>
+          <p:cNvSpPr txBox="1"/>
+          <p:nvPr/>
+        </p:nvSpPr>
+        <p:spPr>
+          <a:xfrm>
+            <a:off x="444500" y="524470"/>
+            <a:ext cx="11493500" cy="640794"/>
+          </a:xfrm>
+          <a:prstGeom prst="rect">
+            <a:avLst/>
+          </a:prstGeom>
+          <a:noFill/>
+        </p:spPr>
+        <p:txBody>
+          <a:bodyPr wrap="none" lIns="0" rIns="0" tIns="0" bIns="0" anchor="t">
+            <a:spAutoFit/>
+          </a:bodyPr>
+          <a:lstStyle/>
+          <a:p>
+            <a:pPr algn="l">
+              <a:lnSpc>
+                <a:spcPct val="104000"/>
+              </a:lnSpc>
+            </a:pPr>
+            <a:r>
+              <a:rPr sz="4060" b="1" spc="-145">
+                <a:solidFill>
+                  <a:srgbClr val="1D1D1F"/>
+                </a:solidFill>
+                <a:latin typeface="Helvetica Neue"/>
+              </a:rPr>
+              <a:t>Karen sits </a:t>
+            </a:r>
+            <a:r>
+              <a:rPr sz="4060" b="1" spc="-145">
+                <a:solidFill>
+                  <a:srgbClr val="0071E3"/>
+                </a:solidFill>
+                <a:latin typeface="Helvetica Neue"/>
+              </a:rPr>
+              <a:t>in the call</a:t>
+            </a:r>
+            <a:r>
+              <a:rPr sz="4060" b="1" spc="-145">
+                <a:solidFill>
+                  <a:srgbClr val="1D1D1F"/>
+                </a:solidFill>
+                <a:latin typeface="Helvetica Neue"/>
+              </a:rPr>
+              <a:t>.</a:t>
+            </a:r>
+          </a:p>
+        </p:txBody>
+      </p:sp>
+      <p:sp>
+        <p:nvSpPr>
+          <p:cNvPr id="8" name="TextBox 7"/>
+          <p:cNvSpPr txBox="1"/>
+          <p:nvPr/>
+        </p:nvSpPr>
+        <p:spPr>
+          <a:xfrm>
+            <a:off x="444500" y="974129"/>
+            <a:ext cx="11493500" cy="293370"/>
+          </a:xfrm>
+          <a:prstGeom prst="rect">
+            <a:avLst/>
+          </a:prstGeom>
+          <a:noFill/>
+        </p:spPr>
+        <p:txBody>
+          <a:bodyPr wrap="none" lIns="0" rIns="0" tIns="0" bIns="0" anchor="t">
+            <a:spAutoFit/>
+          </a:bodyPr>
+          <a:lstStyle/>
+          <a:p>
+            <a:pPr algn="l">
+              <a:lnSpc>
+                <a:spcPct val="150000"/>
+              </a:lnSpc>
+            </a:pPr>
+            <a:r>
+              <a:rPr sz="1470" b="0">
+                <a:solidFill>
+                  <a:srgbClr val="6E6E73"/>
+                </a:solidFill>
+                <a:latin typeface="Helvetica Neue"/>
+              </a:rPr>
+              <a:t>Hears everyone. Decides in code. Speaks up.</a:t>
+            </a:r>
+          </a:p>
+        </p:txBody>
+      </p:sp>
+      <p:sp>
+        <p:nvSpPr>
+          <p:cNvPr id="9" name="TextBox 8"/>
+          <p:cNvSpPr txBox="1"/>
+          <p:nvPr/>
+        </p:nvSpPr>
+        <p:spPr>
+          <a:xfrm>
+            <a:off x="809724" y="4001392"/>
+            <a:ext cx="880179" cy="265430"/>
+          </a:xfrm>
+          <a:prstGeom prst="rect">
+            <a:avLst/>
+          </a:prstGeom>
+          <a:noFill/>
+        </p:spPr>
+        <p:txBody>
+          <a:bodyPr wrap="none" lIns="0" rIns="0" tIns="0" bIns="0" anchor="t">
+            <a:spAutoFit/>
+          </a:bodyPr>
+          <a:lstStyle/>
+          <a:p>
+            <a:pPr algn="l">
+              <a:lnSpc>
+                <a:spcPct val="150000"/>
+              </a:lnSpc>
+            </a:pPr>
+            <a:r>
+              <a:rPr sz="1330" b="1">
+                <a:solidFill>
+                  <a:srgbClr val="1D1D1F"/>
+                </a:solidFill>
+                <a:latin typeface="Helvetica Neue"/>
+              </a:rPr>
+              <a:t>Karen</a:t>
+            </a:r>
+          </a:p>
+        </p:txBody>
+      </p:sp>
+      <p:sp>
+        <p:nvSpPr>
+          <p:cNvPr id="10" name="TextBox 9"/>
+          <p:cNvSpPr txBox="1"/>
+          <p:nvPr/>
+        </p:nvSpPr>
+        <p:spPr>
+          <a:xfrm>
+            <a:off x="690264" y="4245867"/>
+            <a:ext cx="1270625" cy="195579"/>
+          </a:xfrm>
+          <a:prstGeom prst="rect">
+            <a:avLst/>
+          </a:prstGeom>
+          <a:noFill/>
+        </p:spPr>
+        <p:txBody>
+          <a:bodyPr wrap="none" lIns="0" rIns="0" tIns="0" bIns="0" anchor="t">
+            <a:spAutoFit/>
+          </a:bodyPr>
+          <a:lstStyle/>
+          <a:p>
+            <a:pPr algn="l">
+              <a:lnSpc>
+                <a:spcPct val="150000"/>
+              </a:lnSpc>
+            </a:pPr>
+            <a:r>
+              <a:rPr sz="980" b="0" spc="196">
+                <a:solidFill>
+                  <a:srgbClr val="6E6E73"/>
+                </a:solidFill>
+                <a:latin typeface="Helvetica Neue"/>
+              </a:rPr>
+              <a:t>THE CHAIR</a:t>
+            </a:r>
+          </a:p>
+        </p:txBody>
+      </p:sp>
+      <p:sp>
+        <p:nvSpPr>
+          <p:cNvPr id="11" name="TextBox 10"/>
+          <p:cNvSpPr txBox="1"/>
+          <p:nvPr/>
+        </p:nvSpPr>
+        <p:spPr>
+          <a:xfrm>
+            <a:off x="1924050" y="2384623"/>
+            <a:ext cx="5227022" cy="237490"/>
+          </a:xfrm>
+          <a:prstGeom prst="rect">
+            <a:avLst/>
+          </a:prstGeom>
+          <a:noFill/>
+        </p:spPr>
+        <p:txBody>
+          <a:bodyPr wrap="none" lIns="0" rIns="0" tIns="0" bIns="0" anchor="t">
+            <a:spAutoFit/>
+          </a:bodyPr>
+          <a:lstStyle/>
+          <a:p>
+            <a:pPr algn="l">
+              <a:lnSpc>
+                <a:spcPct val="150000"/>
+              </a:lnSpc>
+            </a:pPr>
+            <a:r>
+              <a:rPr sz="1190" b="1" spc="340">
+                <a:solidFill>
+                  <a:srgbClr val="087443"/>
+                </a:solidFill>
+                <a:latin typeface="Helvetica Neue"/>
+              </a:rPr>
+              <a:t>HEAR</a:t>
+            </a:r>
+          </a:p>
+        </p:txBody>
+      </p:sp>
+      <p:sp>
+        <p:nvSpPr>
+          <p:cNvPr id="12" name="TextBox 11"/>
+          <p:cNvSpPr txBox="1"/>
+          <p:nvPr/>
+        </p:nvSpPr>
+        <p:spPr>
+          <a:xfrm>
+            <a:off x="2355850" y="3077467"/>
+            <a:ext cx="1409263" cy="363220"/>
+          </a:xfrm>
+          <a:prstGeom prst="rect">
+            <a:avLst/>
+          </a:prstGeom>
+          <a:noFill/>
+        </p:spPr>
+        <p:txBody>
+          <a:bodyPr wrap="none" lIns="0" rIns="0" tIns="0" bIns="0" anchor="t">
+            <a:spAutoFit/>
+          </a:bodyPr>
+          <a:lstStyle/>
+          <a:p>
+            <a:pPr algn="l">
+              <a:lnSpc>
+                <a:spcPct val="150000"/>
+              </a:lnSpc>
+            </a:pPr>
+            <a:r>
+              <a:rPr sz="1820" b="1" spc="-26">
+                <a:solidFill>
+                  <a:srgbClr val="1D1D1F"/>
+                </a:solidFill>
+                <a:latin typeface="Helvetica Neue"/>
+              </a:rPr>
+              <a:t>Discord</a:t>
+            </a:r>
+          </a:p>
+        </p:txBody>
+      </p:sp>
+      <p:sp>
+        <p:nvSpPr>
+          <p:cNvPr id="13" name="TextBox 12"/>
+          <p:cNvSpPr txBox="1"/>
+          <p:nvPr/>
+        </p:nvSpPr>
+        <p:spPr>
+          <a:xfrm>
+            <a:off x="2355850" y="3331467"/>
+            <a:ext cx="1307663" cy="251460"/>
+          </a:xfrm>
+          <a:prstGeom prst="rect">
+            <a:avLst/>
+          </a:prstGeom>
+          <a:noFill/>
+        </p:spPr>
+        <p:txBody>
+          <a:bodyPr wrap="none" lIns="0" rIns="0" tIns="0" bIns="0" anchor="t">
+            <a:spAutoFit/>
+          </a:bodyPr>
+          <a:lstStyle/>
+          <a:p>
+            <a:pPr algn="l">
+              <a:lnSpc>
+                <a:spcPct val="150000"/>
+              </a:lnSpc>
+            </a:pPr>
+            <a:r>
+              <a:rPr sz="1260" b="0" spc="36">
+                <a:solidFill>
+                  <a:srgbClr val="6E6E73"/>
+                </a:solidFill>
+                <a:latin typeface="Helvetica Neue"/>
+              </a:rPr>
+              <a:t>the call</a:t>
+            </a:r>
+          </a:p>
+        </p:txBody>
+      </p:sp>
+      <p:sp>
+        <p:nvSpPr>
+          <p:cNvPr id="14" name="TextBox 13"/>
+          <p:cNvSpPr txBox="1"/>
+          <p:nvPr/>
+        </p:nvSpPr>
+        <p:spPr>
+          <a:xfrm>
+            <a:off x="2355850" y="4033837"/>
+            <a:ext cx="1762918" cy="363220"/>
+          </a:xfrm>
+          <a:prstGeom prst="rect">
+            <a:avLst/>
+          </a:prstGeom>
+          <a:noFill/>
+        </p:spPr>
+        <p:txBody>
+          <a:bodyPr wrap="none" lIns="0" rIns="0" tIns="0" bIns="0" anchor="t">
+            <a:spAutoFit/>
+          </a:bodyPr>
+          <a:lstStyle/>
+          <a:p>
+            <a:pPr algn="l">
+              <a:lnSpc>
+                <a:spcPct val="150000"/>
+              </a:lnSpc>
+            </a:pPr>
+            <a:r>
+              <a:rPr sz="1820" b="1" spc="-26">
+                <a:solidFill>
+                  <a:srgbClr val="1D1D1F"/>
+                </a:solidFill>
+                <a:latin typeface="Helvetica Neue"/>
+              </a:rPr>
+              <a:t>SLNG</a:t>
+            </a:r>
+          </a:p>
+        </p:txBody>
+      </p:sp>
+      <p:sp>
+        <p:nvSpPr>
+          <p:cNvPr id="15" name="TextBox 14"/>
+          <p:cNvSpPr txBox="1"/>
+          <p:nvPr/>
+        </p:nvSpPr>
+        <p:spPr>
+          <a:xfrm>
+            <a:off x="2355850" y="4287837"/>
+            <a:ext cx="1661318" cy="251460"/>
+          </a:xfrm>
+          <a:prstGeom prst="rect">
+            <a:avLst/>
+          </a:prstGeom>
+          <a:noFill/>
+        </p:spPr>
+        <p:txBody>
+          <a:bodyPr wrap="none" lIns="0" rIns="0" tIns="0" bIns="0" anchor="t">
+            <a:spAutoFit/>
+          </a:bodyPr>
+          <a:lstStyle/>
+          <a:p>
+            <a:pPr algn="l">
+              <a:lnSpc>
+                <a:spcPct val="150000"/>
+              </a:lnSpc>
+            </a:pPr>
+            <a:r>
+              <a:rPr sz="1260" b="0" spc="36">
+                <a:solidFill>
+                  <a:srgbClr val="6E6E73"/>
+                </a:solidFill>
+                <a:latin typeface="Helvetica Neue"/>
+              </a:rPr>
+              <a:t>speech → text</a:t>
+            </a:r>
+          </a:p>
+        </p:txBody>
+      </p:sp>
+      <p:sp>
+        <p:nvSpPr>
+          <p:cNvPr id="16" name="TextBox 15"/>
+          <p:cNvSpPr txBox="1"/>
+          <p:nvPr/>
+        </p:nvSpPr>
+        <p:spPr>
+          <a:xfrm>
+            <a:off x="2787650" y="4990107"/>
+            <a:ext cx="2549971" cy="363220"/>
+          </a:xfrm>
+          <a:prstGeom prst="rect">
+            <a:avLst/>
+          </a:prstGeom>
+          <a:noFill/>
+        </p:spPr>
+        <p:txBody>
+          <a:bodyPr wrap="none" lIns="0" rIns="0" tIns="0" bIns="0" anchor="t">
+            <a:spAutoFit/>
+          </a:bodyPr>
+          <a:lstStyle/>
+          <a:p>
+            <a:pPr algn="l">
+              <a:lnSpc>
+                <a:spcPct val="150000"/>
+              </a:lnSpc>
+            </a:pPr>
+            <a:r>
+              <a:rPr sz="1820" b="1" spc="-26">
+                <a:solidFill>
+                  <a:srgbClr val="1D1D1F"/>
+                </a:solidFill>
+                <a:latin typeface="Helvetica Neue"/>
+              </a:rPr>
+              <a:t>Postgres · Redis</a:t>
+            </a:r>
+          </a:p>
+        </p:txBody>
+      </p:sp>
+      <p:sp>
+        <p:nvSpPr>
+          <p:cNvPr id="17" name="TextBox 16"/>
+          <p:cNvSpPr txBox="1"/>
+          <p:nvPr/>
+        </p:nvSpPr>
+        <p:spPr>
+          <a:xfrm>
+            <a:off x="2787650" y="5244107"/>
+            <a:ext cx="2448371" cy="251460"/>
+          </a:xfrm>
+          <a:prstGeom prst="rect">
+            <a:avLst/>
+          </a:prstGeom>
+          <a:noFill/>
+        </p:spPr>
+        <p:txBody>
+          <a:bodyPr wrap="none" lIns="0" rIns="0" tIns="0" bIns="0" anchor="t">
+            <a:spAutoFit/>
+          </a:bodyPr>
+          <a:lstStyle/>
+          <a:p>
+            <a:pPr algn="l">
+              <a:lnSpc>
+                <a:spcPct val="150000"/>
+              </a:lnSpc>
+            </a:pPr>
+            <a:r>
+              <a:rPr sz="1260" b="0" spc="36">
+                <a:solidFill>
+                  <a:srgbClr val="6E6E73"/>
+                </a:solidFill>
+                <a:latin typeface="Helvetica Neue"/>
+              </a:rPr>
+              <a:t>memory</a:t>
+            </a:r>
+          </a:p>
+        </p:txBody>
+      </p:sp>
+      <p:sp>
+        <p:nvSpPr>
+          <p:cNvPr id="18" name="TextBox 17"/>
+          <p:cNvSpPr txBox="1"/>
+          <p:nvPr/>
+        </p:nvSpPr>
+        <p:spPr>
+          <a:xfrm>
+            <a:off x="4885332" y="3510855"/>
+            <a:ext cx="855156" cy="388620"/>
+          </a:xfrm>
+          <a:prstGeom prst="rect">
+            <a:avLst/>
+          </a:prstGeom>
+          <a:noFill/>
+        </p:spPr>
+        <p:txBody>
+          <a:bodyPr wrap="none" lIns="0" rIns="0" tIns="0" bIns="0" anchor="t">
+            <a:spAutoFit/>
+          </a:bodyPr>
+          <a:lstStyle/>
+          <a:p>
+            <a:pPr algn="l">
+              <a:lnSpc>
+                <a:spcPct val="100000"/>
+              </a:lnSpc>
+            </a:pPr>
+            <a:r>
+              <a:rPr sz="2520" b="0">
+                <a:solidFill>
+                  <a:srgbClr val="C2C6D2"/>
+                </a:solidFill>
+                <a:latin typeface="Helvetica Neue"/>
+              </a:rPr>
+              <a:t>→</a:t>
+            </a:r>
+          </a:p>
+        </p:txBody>
+      </p:sp>
+      <p:sp>
+        <p:nvSpPr>
+          <p:cNvPr id="19" name="TextBox 18"/>
+          <p:cNvSpPr txBox="1"/>
+          <p:nvPr/>
+        </p:nvSpPr>
+        <p:spPr>
+          <a:xfrm>
+            <a:off x="5418633" y="2384623"/>
+            <a:ext cx="5227022" cy="237490"/>
+          </a:xfrm>
+          <a:prstGeom prst="rect">
+            <a:avLst/>
+          </a:prstGeom>
+          <a:noFill/>
+        </p:spPr>
+        <p:txBody>
+          <a:bodyPr wrap="none" lIns="0" rIns="0" tIns="0" bIns="0" anchor="t">
+            <a:spAutoFit/>
+          </a:bodyPr>
+          <a:lstStyle/>
+          <a:p>
+            <a:pPr algn="l">
+              <a:lnSpc>
+                <a:spcPct val="150000"/>
+              </a:lnSpc>
+            </a:pPr>
+            <a:r>
+              <a:rPr sz="1190" b="1" spc="340">
+                <a:solidFill>
+                  <a:srgbClr val="0071E3"/>
+                </a:solidFill>
+                <a:latin typeface="Helvetica Neue"/>
+              </a:rPr>
+              <a:t>THINK</a:t>
+            </a:r>
+          </a:p>
+        </p:txBody>
+      </p:sp>
+      <p:sp>
+        <p:nvSpPr>
+          <p:cNvPr id="20" name="TextBox 19"/>
+          <p:cNvSpPr txBox="1"/>
+          <p:nvPr/>
+        </p:nvSpPr>
+        <p:spPr>
+          <a:xfrm>
+            <a:off x="5850433" y="3077467"/>
+            <a:ext cx="1700143" cy="363220"/>
+          </a:xfrm>
+          <a:prstGeom prst="rect">
+            <a:avLst/>
+          </a:prstGeom>
+          <a:noFill/>
+        </p:spPr>
+        <p:txBody>
+          <a:bodyPr wrap="none" lIns="0" rIns="0" tIns="0" bIns="0" anchor="t">
+            <a:spAutoFit/>
+          </a:bodyPr>
+          <a:lstStyle/>
+          <a:p>
+            <a:pPr algn="l">
+              <a:lnSpc>
+                <a:spcPct val="150000"/>
+              </a:lnSpc>
+            </a:pPr>
+            <a:r>
+              <a:rPr sz="1820" b="1" spc="-26">
+                <a:solidFill>
+                  <a:srgbClr val="1D1D1F"/>
+                </a:solidFill>
+                <a:latin typeface="Helvetica Neue"/>
+              </a:rPr>
+              <a:t>Rules</a:t>
+            </a:r>
+          </a:p>
+        </p:txBody>
+      </p:sp>
+      <p:sp>
+        <p:nvSpPr>
+          <p:cNvPr id="21" name="TextBox 20"/>
+          <p:cNvSpPr txBox="1"/>
+          <p:nvPr/>
+        </p:nvSpPr>
+        <p:spPr>
+          <a:xfrm>
+            <a:off x="5850433" y="3331467"/>
+            <a:ext cx="1598543" cy="251460"/>
+          </a:xfrm>
+          <a:prstGeom prst="rect">
+            <a:avLst/>
+          </a:prstGeom>
+          <a:noFill/>
+        </p:spPr>
+        <p:txBody>
+          <a:bodyPr wrap="none" lIns="0" rIns="0" tIns="0" bIns="0" anchor="t">
+            <a:spAutoFit/>
+          </a:bodyPr>
+          <a:lstStyle/>
+          <a:p>
+            <a:pPr algn="l">
+              <a:lnSpc>
+                <a:spcPct val="150000"/>
+              </a:lnSpc>
+            </a:pPr>
+            <a:r>
+              <a:rPr sz="1260" b="0" spc="36">
+                <a:solidFill>
+                  <a:srgbClr val="6E6E73"/>
+                </a:solidFill>
+                <a:latin typeface="Helvetica Neue"/>
+              </a:rPr>
+              <a:t>every 250 ms</a:t>
+            </a:r>
+          </a:p>
+        </p:txBody>
+      </p:sp>
+      <p:sp>
+        <p:nvSpPr>
+          <p:cNvPr id="22" name="TextBox 21"/>
+          <p:cNvSpPr txBox="1"/>
+          <p:nvPr/>
+        </p:nvSpPr>
+        <p:spPr>
+          <a:xfrm>
+            <a:off x="5850433" y="4033837"/>
+            <a:ext cx="1300301" cy="363220"/>
+          </a:xfrm>
+          <a:prstGeom prst="rect">
+            <a:avLst/>
+          </a:prstGeom>
+          <a:noFill/>
+        </p:spPr>
+        <p:txBody>
+          <a:bodyPr wrap="none" lIns="0" rIns="0" tIns="0" bIns="0" anchor="t">
+            <a:spAutoFit/>
+          </a:bodyPr>
+          <a:lstStyle/>
+          <a:p>
+            <a:pPr algn="l">
+              <a:lnSpc>
+                <a:spcPct val="150000"/>
+              </a:lnSpc>
+            </a:pPr>
+            <a:r>
+              <a:rPr sz="1820" b="1" spc="-26">
+                <a:solidFill>
+                  <a:srgbClr val="1D1D1F"/>
+                </a:solidFill>
+                <a:latin typeface="Helvetica Neue"/>
+              </a:rPr>
+              <a:t>Mastra</a:t>
+            </a:r>
+          </a:p>
+        </p:txBody>
+      </p:sp>
+      <p:sp>
+        <p:nvSpPr>
+          <p:cNvPr id="23" name="TextBox 22"/>
+          <p:cNvSpPr txBox="1"/>
+          <p:nvPr/>
+        </p:nvSpPr>
+        <p:spPr>
+          <a:xfrm>
+            <a:off x="5850433" y="4287837"/>
+            <a:ext cx="1198701" cy="251460"/>
+          </a:xfrm>
+          <a:prstGeom prst="rect">
+            <a:avLst/>
+          </a:prstGeom>
+          <a:noFill/>
+        </p:spPr>
+        <p:txBody>
+          <a:bodyPr wrap="none" lIns="0" rIns="0" tIns="0" bIns="0" anchor="t">
+            <a:spAutoFit/>
+          </a:bodyPr>
+          <a:lstStyle/>
+          <a:p>
+            <a:pPr algn="l">
+              <a:lnSpc>
+                <a:spcPct val="150000"/>
+              </a:lnSpc>
+            </a:pPr>
+            <a:r>
+              <a:rPr sz="1260" b="0" spc="36">
+                <a:solidFill>
+                  <a:srgbClr val="6E6E73"/>
+                </a:solidFill>
+                <a:latin typeface="Helvetica Neue"/>
+              </a:rPr>
+              <a:t>the agent</a:t>
+            </a:r>
+          </a:p>
+        </p:txBody>
+      </p:sp>
+      <p:sp>
+        <p:nvSpPr>
+          <p:cNvPr id="24" name="TextBox 23"/>
+          <p:cNvSpPr txBox="1"/>
+          <p:nvPr/>
+        </p:nvSpPr>
+        <p:spPr>
+          <a:xfrm>
+            <a:off x="5850433" y="4990107"/>
+            <a:ext cx="1326693" cy="363220"/>
+          </a:xfrm>
+          <a:prstGeom prst="rect">
+            <a:avLst/>
+          </a:prstGeom>
+          <a:noFill/>
+        </p:spPr>
+        <p:txBody>
+          <a:bodyPr wrap="none" lIns="0" rIns="0" tIns="0" bIns="0" anchor="t">
+            <a:spAutoFit/>
+          </a:bodyPr>
+          <a:lstStyle/>
+          <a:p>
+            <a:pPr algn="l">
+              <a:lnSpc>
+                <a:spcPct val="150000"/>
+              </a:lnSpc>
+            </a:pPr>
+            <a:r>
+              <a:rPr sz="1820" b="1" spc="-26">
+                <a:solidFill>
+                  <a:srgbClr val="1D1D1F"/>
+                </a:solidFill>
+                <a:latin typeface="Helvetica Neue"/>
+              </a:rPr>
+              <a:t>Nebius</a:t>
+            </a:r>
+          </a:p>
+        </p:txBody>
+      </p:sp>
+      <p:sp>
+        <p:nvSpPr>
+          <p:cNvPr id="25" name="TextBox 24"/>
+          <p:cNvSpPr txBox="1"/>
+          <p:nvPr/>
+        </p:nvSpPr>
+        <p:spPr>
+          <a:xfrm>
+            <a:off x="5850433" y="5244107"/>
+            <a:ext cx="1225093" cy="251460"/>
+          </a:xfrm>
+          <a:prstGeom prst="rect">
+            <a:avLst/>
+          </a:prstGeom>
+          <a:noFill/>
+        </p:spPr>
+        <p:txBody>
+          <a:bodyPr wrap="none" lIns="0" rIns="0" tIns="0" bIns="0" anchor="t">
+            <a:spAutoFit/>
+          </a:bodyPr>
+          <a:lstStyle/>
+          <a:p>
+            <a:pPr algn="l">
+              <a:lnSpc>
+                <a:spcPct val="150000"/>
+              </a:lnSpc>
+            </a:pPr>
+            <a:r>
+              <a:rPr sz="1260" b="0" spc="36">
+                <a:solidFill>
+                  <a:srgbClr val="6E6E73"/>
+                </a:solidFill>
+                <a:latin typeface="Helvetica Neue"/>
+              </a:rPr>
+              <a:t>the words</a:t>
+            </a:r>
+          </a:p>
+        </p:txBody>
+      </p:sp>
+      <p:sp>
+        <p:nvSpPr>
+          <p:cNvPr id="26" name="TextBox 25"/>
+          <p:cNvSpPr txBox="1"/>
+          <p:nvPr/>
+        </p:nvSpPr>
+        <p:spPr>
+          <a:xfrm>
+            <a:off x="8379916" y="3510855"/>
+            <a:ext cx="855156" cy="388620"/>
+          </a:xfrm>
+          <a:prstGeom prst="rect">
+            <a:avLst/>
+          </a:prstGeom>
+          <a:noFill/>
+        </p:spPr>
+        <p:txBody>
+          <a:bodyPr wrap="none" lIns="0" rIns="0" tIns="0" bIns="0" anchor="t">
+            <a:spAutoFit/>
+          </a:bodyPr>
+          <a:lstStyle/>
+          <a:p>
+            <a:pPr algn="l">
+              <a:lnSpc>
+                <a:spcPct val="100000"/>
+              </a:lnSpc>
+            </a:pPr>
+            <a:r>
+              <a:rPr sz="2520" b="0">
+                <a:solidFill>
+                  <a:srgbClr val="C2C6D2"/>
+                </a:solidFill>
+                <a:latin typeface="Helvetica Neue"/>
+              </a:rPr>
+              <a:t>→</a:t>
+            </a:r>
+          </a:p>
+        </p:txBody>
+      </p:sp>
+      <p:sp>
+        <p:nvSpPr>
+          <p:cNvPr id="27" name="TextBox 26"/>
+          <p:cNvSpPr txBox="1"/>
+          <p:nvPr/>
+        </p:nvSpPr>
+        <p:spPr>
+          <a:xfrm>
+            <a:off x="8913217" y="2384623"/>
+            <a:ext cx="3024782" cy="237490"/>
+          </a:xfrm>
+          <a:prstGeom prst="rect">
+            <a:avLst/>
+          </a:prstGeom>
+          <a:noFill/>
+        </p:spPr>
+        <p:txBody>
+          <a:bodyPr wrap="none" lIns="0" rIns="0" tIns="0" bIns="0" anchor="t">
+            <a:spAutoFit/>
+          </a:bodyPr>
+          <a:lstStyle/>
+          <a:p>
+            <a:pPr algn="l">
+              <a:lnSpc>
+                <a:spcPct val="150000"/>
+              </a:lnSpc>
+            </a:pPr>
+            <a:r>
+              <a:rPr sz="1190" b="1" spc="340">
+                <a:solidFill>
+                  <a:srgbClr val="B25000"/>
+                </a:solidFill>
+                <a:latin typeface="Helvetica Neue"/>
+              </a:rPr>
+              <a:t>SPEAK</a:t>
+            </a:r>
+          </a:p>
+        </p:txBody>
+      </p:sp>
+      <p:sp>
+        <p:nvSpPr>
+          <p:cNvPr id="28" name="TextBox 27"/>
+          <p:cNvSpPr txBox="1"/>
+          <p:nvPr/>
+        </p:nvSpPr>
+        <p:spPr>
+          <a:xfrm>
+            <a:off x="9345017" y="3077467"/>
+            <a:ext cx="1762918" cy="363220"/>
+          </a:xfrm>
+          <a:prstGeom prst="rect">
+            <a:avLst/>
+          </a:prstGeom>
+          <a:noFill/>
+        </p:spPr>
+        <p:txBody>
+          <a:bodyPr wrap="none" lIns="0" rIns="0" tIns="0" bIns="0" anchor="t">
+            <a:spAutoFit/>
+          </a:bodyPr>
+          <a:lstStyle/>
+          <a:p>
+            <a:pPr algn="l">
+              <a:lnSpc>
+                <a:spcPct val="150000"/>
+              </a:lnSpc>
+            </a:pPr>
+            <a:r>
+              <a:rPr sz="1820" b="1" spc="-26">
+                <a:solidFill>
+                  <a:srgbClr val="1D1D1F"/>
+                </a:solidFill>
+                <a:latin typeface="Helvetica Neue"/>
+              </a:rPr>
+              <a:t>SLNG</a:t>
+            </a:r>
+          </a:p>
+        </p:txBody>
+      </p:sp>
+      <p:sp>
+        <p:nvSpPr>
+          <p:cNvPr id="29" name="TextBox 28"/>
+          <p:cNvSpPr txBox="1"/>
+          <p:nvPr/>
+        </p:nvSpPr>
+        <p:spPr>
+          <a:xfrm>
+            <a:off x="9345017" y="3331467"/>
+            <a:ext cx="1661318" cy="251460"/>
+          </a:xfrm>
+          <a:prstGeom prst="rect">
+            <a:avLst/>
+          </a:prstGeom>
+          <a:noFill/>
+        </p:spPr>
+        <p:txBody>
+          <a:bodyPr wrap="none" lIns="0" rIns="0" tIns="0" bIns="0" anchor="t">
+            <a:spAutoFit/>
+          </a:bodyPr>
+          <a:lstStyle/>
+          <a:p>
+            <a:pPr algn="l">
+              <a:lnSpc>
+                <a:spcPct val="150000"/>
+              </a:lnSpc>
+            </a:pPr>
+            <a:r>
+              <a:rPr sz="1260" b="0" spc="36">
+                <a:solidFill>
+                  <a:srgbClr val="6E6E73"/>
+                </a:solidFill>
+                <a:latin typeface="Helvetica Neue"/>
+              </a:rPr>
+              <a:t>text → speech</a:t>
+            </a:r>
+          </a:p>
+        </p:txBody>
+      </p:sp>
+      <p:sp>
+        <p:nvSpPr>
+          <p:cNvPr id="30" name="TextBox 29"/>
+          <p:cNvSpPr txBox="1"/>
+          <p:nvPr/>
+        </p:nvSpPr>
+        <p:spPr>
+          <a:xfrm>
+            <a:off x="9345017" y="4033837"/>
+            <a:ext cx="1154013" cy="363220"/>
+          </a:xfrm>
+          <a:prstGeom prst="rect">
+            <a:avLst/>
+          </a:prstGeom>
+          <a:noFill/>
+        </p:spPr>
+        <p:txBody>
+          <a:bodyPr wrap="none" lIns="0" rIns="0" tIns="0" bIns="0" anchor="t">
+            <a:spAutoFit/>
+          </a:bodyPr>
+          <a:lstStyle/>
+          <a:p>
+            <a:pPr algn="l">
+              <a:lnSpc>
+                <a:spcPct val="150000"/>
+              </a:lnSpc>
+            </a:pPr>
+            <a:r>
+              <a:rPr sz="1820" b="1" spc="-26">
+                <a:solidFill>
+                  <a:srgbClr val="1D1D1F"/>
+                </a:solidFill>
+                <a:latin typeface="Helvetica Neue"/>
+              </a:rPr>
+              <a:t>fal</a:t>
+            </a:r>
+          </a:p>
+        </p:txBody>
+      </p:sp>
+      <p:sp>
+        <p:nvSpPr>
+          <p:cNvPr id="31" name="TextBox 30"/>
+          <p:cNvSpPr txBox="1"/>
+          <p:nvPr/>
+        </p:nvSpPr>
+        <p:spPr>
+          <a:xfrm>
+            <a:off x="9345017" y="4287837"/>
+            <a:ext cx="1052413" cy="251460"/>
+          </a:xfrm>
+          <a:prstGeom prst="rect">
+            <a:avLst/>
+          </a:prstGeom>
+          <a:noFill/>
+        </p:spPr>
+        <p:txBody>
+          <a:bodyPr wrap="none" lIns="0" rIns="0" tIns="0" bIns="0" anchor="t">
+            <a:spAutoFit/>
+          </a:bodyPr>
+          <a:lstStyle/>
+          <a:p>
+            <a:pPr algn="l">
+              <a:lnSpc>
+                <a:spcPct val="150000"/>
+              </a:lnSpc>
+            </a:pPr>
+            <a:r>
+              <a:rPr sz="1260" b="0" spc="36">
+                <a:solidFill>
+                  <a:srgbClr val="6E6E73"/>
+                </a:solidFill>
+                <a:latin typeface="Helvetica Neue"/>
+              </a:rPr>
+              <a:t>her face</a:t>
+            </a:r>
+          </a:p>
+        </p:txBody>
+      </p:sp>
+      <p:sp>
+        <p:nvSpPr>
+          <p:cNvPr id="32" name="TextBox 31"/>
+          <p:cNvSpPr txBox="1"/>
+          <p:nvPr/>
+        </p:nvSpPr>
+        <p:spPr>
+          <a:xfrm>
+            <a:off x="9345017" y="4990107"/>
+            <a:ext cx="1391165" cy="363220"/>
+          </a:xfrm>
+          <a:prstGeom prst="rect">
+            <a:avLst/>
+          </a:prstGeom>
+          <a:noFill/>
+        </p:spPr>
+        <p:txBody>
+          <a:bodyPr wrap="none" lIns="0" rIns="0" tIns="0" bIns="0" anchor="t">
+            <a:spAutoFit/>
+          </a:bodyPr>
+          <a:lstStyle/>
+          <a:p>
+            <a:pPr algn="l">
+              <a:lnSpc>
+                <a:spcPct val="150000"/>
+              </a:lnSpc>
+            </a:pPr>
+            <a:r>
+              <a:rPr sz="1820" b="1" spc="-26">
+                <a:solidFill>
+                  <a:srgbClr val="1D1D1F"/>
+                </a:solidFill>
+                <a:latin typeface="Helvetica Neue"/>
+              </a:rPr>
+              <a:t>Vonage</a:t>
+            </a:r>
+          </a:p>
+        </p:txBody>
+      </p:sp>
+      <p:sp>
+        <p:nvSpPr>
+          <p:cNvPr id="33" name="TextBox 32"/>
+          <p:cNvSpPr txBox="1"/>
+          <p:nvPr/>
+        </p:nvSpPr>
+        <p:spPr>
+          <a:xfrm>
+            <a:off x="9345017" y="5244107"/>
+            <a:ext cx="1289565" cy="251460"/>
+          </a:xfrm>
+          <a:prstGeom prst="rect">
+            <a:avLst/>
+          </a:prstGeom>
+          <a:noFill/>
+        </p:spPr>
+        <p:txBody>
+          <a:bodyPr wrap="none" lIns="0" rIns="0" tIns="0" bIns="0" anchor="t">
+            <a:spAutoFit/>
+          </a:bodyPr>
+          <a:lstStyle/>
+          <a:p>
+            <a:pPr algn="l">
+              <a:lnSpc>
+                <a:spcPct val="150000"/>
+              </a:lnSpc>
+            </a:pPr>
+            <a:r>
+              <a:rPr sz="1260" b="0" spc="36">
+                <a:solidFill>
+                  <a:srgbClr val="6E6E73"/>
+                </a:solidFill>
+                <a:latin typeface="Helvetica Neue"/>
+              </a:rPr>
+              <a:t>the stage</a:t>
+            </a:r>
+          </a:p>
+        </p:txBody>
+      </p:sp>
+      <p:sp>
+        <p:nvSpPr>
+          <p:cNvPr id="34" name="TextBox 33"/>
+          <p:cNvSpPr txBox="1"/>
+          <p:nvPr/>
+        </p:nvSpPr>
+        <p:spPr>
+          <a:xfrm>
+            <a:off x="10515203" y="6130329"/>
+            <a:ext cx="1422796" cy="223520"/>
+          </a:xfrm>
+          <a:prstGeom prst="rect">
+            <a:avLst/>
+          </a:prstGeom>
+          <a:noFill/>
+        </p:spPr>
+        <p:txBody>
+          <a:bodyPr wrap="none" lIns="0" rIns="0" tIns="0" bIns="0" anchor="t">
+            <a:spAutoFit/>
+          </a:bodyPr>
+          <a:lstStyle/>
+          <a:p>
+            <a:pPr algn="l">
+              <a:lnSpc>
+                <a:spcPct val="150000"/>
+              </a:lnSpc>
+            </a:pPr>
+            <a:r>
+              <a:rPr sz="1120" b="0">
+                <a:solidFill>
+                  <a:srgbClr val="6E6E73"/>
+                </a:solidFill>
+                <a:latin typeface="Helvetica Neue"/>
+              </a:rPr>
+              <a:t>back into the same call</a:t>
+            </a:r>
+          </a:p>
+        </p:txBody>
+      </p:sp>
+      <p:sp>
+        <p:nvSpPr>
+          <p:cNvPr id="35" name="TextBox 34"/>
+          <p:cNvSpPr txBox="1"/>
+          <p:nvPr/>
+        </p:nvSpPr>
+        <p:spPr>
+          <a:xfrm>
+            <a:off x="11645900" y="6130329"/>
+            <a:ext cx="292100" cy="223520"/>
+          </a:xfrm>
+          <a:prstGeom prst="rect">
+            <a:avLst/>
+          </a:prstGeom>
+          <a:noFill/>
+        </p:spPr>
+        <p:txBody>
+          <a:bodyPr wrap="none" lIns="0" rIns="0" tIns="0" bIns="0" anchor="t">
+            <a:spAutoFit/>
+          </a:bodyPr>
+          <a:lstStyle/>
+          <a:p>
+            <a:pPr algn="l">
+              <a:lnSpc>
+                <a:spcPct val="150000"/>
+              </a:lnSpc>
+            </a:pPr>
+            <a:r>
+              <a:rPr sz="1120" b="0">
+                <a:solidFill>
+                  <a:srgbClr val="B25000"/>
+                </a:solidFill>
+                <a:latin typeface="Helvetica Neue"/>
+              </a:rPr>
+              <a:t>↩</a:t>
+            </a:r>
+          </a:p>
+        </p:txBody>
+      </p:sp>
     </p:spTree>
   </p:cSld>
   <p:clrMapOvr>
@@ -3685,6 +5025,14 @@
 <file path=ppt/slides/slide2.xml><?xml version="1.0" encoding="utf-8"?>
 <p:sld xmlns:a="http://schemas.openxmlformats.org/drawingml/2006/main" xmlns:p="http://schemas.openxmlformats.org/presentationml/2006/main" xmlns:r="http://schemas.openxmlformats.org/officeDocument/2006/relationships">
   <p:cSld>
+    <p:bg>
+      <p:bgPr>
+        <a:solidFill>
+          <a:srgbClr val="FBFBFD"/>
+        </a:solidFill>
+        <a:effectLst/>
+      </p:bgPr>
+    </p:bg>
     <p:spTree>
       <p:nvGrpSpPr>
         <p:cNvPr id="1" name=""/>
@@ -3692,9 +5040,245 @@
         <p:nvPr/>
       </p:nvGrpSpPr>
       <p:grpSpPr/>
+      <p:sp>
+        <p:nvSpPr>
+          <p:cNvPr id="2" name="Rounded Rectangle 1"/>
+          <p:cNvSpPr/>
+          <p:nvPr/>
+        </p:nvSpPr>
+        <p:spPr>
+          <a:xfrm>
+            <a:off x="444500" y="1324967"/>
+            <a:ext cx="3674467" cy="5053012"/>
+          </a:xfrm>
+          <a:prstGeom prst="roundRect">
+            <a:avLst>
+              <a:gd name="adj" fmla="val 3456"/>
+            </a:avLst>
+          </a:prstGeom>
+          <a:solidFill>
+            <a:srgbClr val="FFFFFF"/>
+          </a:solidFill>
+          <a:ln w="9525">
+            <a:solidFill>
+              <a:srgbClr val="E4E4EA"/>
+            </a:solidFill>
+          </a:ln>
+          <a:effectLst/>
+        </p:spPr>
+        <p:style>
+          <a:lnRef idx="1">
+            <a:schemeClr val="accent1"/>
+          </a:lnRef>
+          <a:fillRef idx="3">
+            <a:schemeClr val="accent1"/>
+          </a:fillRef>
+          <a:effectRef idx="2">
+            <a:schemeClr val="accent1"/>
+          </a:effectRef>
+          <a:fontRef idx="minor">
+            <a:schemeClr val="lt1"/>
+          </a:fontRef>
+        </p:style>
+        <p:txBody>
+          <a:bodyPr rtlCol="0" anchor="ctr"/>
+          <a:lstStyle/>
+          <a:p>
+            <a:pPr algn="ctr"/>
+          </a:p>
+        </p:txBody>
+      </p:sp>
+      <p:sp>
+        <p:nvSpPr>
+          <p:cNvPr id="3" name="Rounded Rectangle 2"/>
+          <p:cNvSpPr/>
+          <p:nvPr/>
+        </p:nvSpPr>
+        <p:spPr>
+          <a:xfrm>
+            <a:off x="4258667" y="1324967"/>
+            <a:ext cx="3674566" cy="5053012"/>
+          </a:xfrm>
+          <a:prstGeom prst="roundRect">
+            <a:avLst>
+              <a:gd name="adj" fmla="val 3456"/>
+            </a:avLst>
+          </a:prstGeom>
+          <a:solidFill>
+            <a:srgbClr val="FFFFFF"/>
+          </a:solidFill>
+          <a:ln w="9525">
+            <a:solidFill>
+              <a:srgbClr val="E4E4EA"/>
+            </a:solidFill>
+          </a:ln>
+          <a:effectLst/>
+        </p:spPr>
+        <p:style>
+          <a:lnRef idx="1">
+            <a:schemeClr val="accent1"/>
+          </a:lnRef>
+          <a:fillRef idx="3">
+            <a:schemeClr val="accent1"/>
+          </a:fillRef>
+          <a:effectRef idx="2">
+            <a:schemeClr val="accent1"/>
+          </a:effectRef>
+          <a:fontRef idx="minor">
+            <a:schemeClr val="lt1"/>
+          </a:fontRef>
+        </p:style>
+        <p:txBody>
+          <a:bodyPr rtlCol="0" anchor="ctr"/>
+          <a:lstStyle/>
+          <a:p>
+            <a:pPr algn="ctr"/>
+          </a:p>
+        </p:txBody>
+      </p:sp>
+      <p:sp>
+        <p:nvSpPr>
+          <p:cNvPr id="4" name="Rounded Rectangle 3"/>
+          <p:cNvSpPr/>
+          <p:nvPr/>
+        </p:nvSpPr>
+        <p:spPr>
+          <a:xfrm>
+            <a:off x="4455517" y="2967136"/>
+            <a:ext cx="3280866" cy="468312"/>
+          </a:xfrm>
+          <a:prstGeom prst="roundRect">
+            <a:avLst>
+              <a:gd name="adj" fmla="val 16271"/>
+            </a:avLst>
+          </a:prstGeom>
+          <a:noFill/>
+          <a:ln w="9525">
+            <a:solidFill>
+              <a:srgbClr val="C9CAD2"/>
+            </a:solidFill>
+          </a:ln>
+          <a:effectLst/>
+        </p:spPr>
+        <p:style>
+          <a:lnRef idx="1">
+            <a:schemeClr val="accent1"/>
+          </a:lnRef>
+          <a:fillRef idx="3">
+            <a:schemeClr val="accent1"/>
+          </a:fillRef>
+          <a:effectRef idx="2">
+            <a:schemeClr val="accent1"/>
+          </a:effectRef>
+          <a:fontRef idx="minor">
+            <a:schemeClr val="lt1"/>
+          </a:fontRef>
+        </p:style>
+        <p:txBody>
+          <a:bodyPr rtlCol="0" anchor="ctr"/>
+          <a:lstStyle/>
+          <a:p>
+            <a:pPr algn="ctr"/>
+          </a:p>
+        </p:txBody>
+      </p:sp>
+      <p:sp>
+        <p:nvSpPr>
+          <p:cNvPr id="5" name="Rounded Rectangle 4"/>
+          <p:cNvSpPr/>
+          <p:nvPr/>
+        </p:nvSpPr>
+        <p:spPr>
+          <a:xfrm>
+            <a:off x="8072933" y="1324967"/>
+            <a:ext cx="3674566" cy="5053012"/>
+          </a:xfrm>
+          <a:prstGeom prst="roundRect">
+            <a:avLst>
+              <a:gd name="adj" fmla="val 3456"/>
+            </a:avLst>
+          </a:prstGeom>
+          <a:solidFill>
+            <a:srgbClr val="FFFFFF"/>
+          </a:solidFill>
+          <a:ln w="9525">
+            <a:solidFill>
+              <a:srgbClr val="E4E4EA"/>
+            </a:solidFill>
+          </a:ln>
+          <a:effectLst/>
+        </p:spPr>
+        <p:style>
+          <a:lnRef idx="1">
+            <a:schemeClr val="accent1"/>
+          </a:lnRef>
+          <a:fillRef idx="3">
+            <a:schemeClr val="accent1"/>
+          </a:fillRef>
+          <a:effectRef idx="2">
+            <a:schemeClr val="accent1"/>
+          </a:effectRef>
+          <a:fontRef idx="minor">
+            <a:schemeClr val="lt1"/>
+          </a:fontRef>
+        </p:style>
+        <p:txBody>
+          <a:bodyPr rtlCol="0" anchor="ctr"/>
+          <a:lstStyle/>
+          <a:p>
+            <a:pPr algn="ctr"/>
+          </a:p>
+        </p:txBody>
+      </p:sp>
+      <p:sp>
+        <p:nvSpPr>
+          <p:cNvPr id="6" name="Rounded Rectangle 5"/>
+          <p:cNvSpPr/>
+          <p:nvPr/>
+        </p:nvSpPr>
+        <p:spPr>
+          <a:xfrm>
+            <a:off x="8269783" y="2967136"/>
+            <a:ext cx="3280866" cy="468312"/>
+          </a:xfrm>
+          <a:prstGeom prst="roundRect">
+            <a:avLst>
+              <a:gd name="adj" fmla="val 16271"/>
+            </a:avLst>
+          </a:prstGeom>
+          <a:noFill/>
+          <a:ln w="9525">
+            <a:solidFill>
+              <a:srgbClr val="C9CAD2"/>
+            </a:solidFill>
+          </a:ln>
+          <a:effectLst/>
+        </p:spPr>
+        <p:style>
+          <a:lnRef idx="1">
+            <a:schemeClr val="accent1"/>
+          </a:lnRef>
+          <a:fillRef idx="3">
+            <a:schemeClr val="accent1"/>
+          </a:fillRef>
+          <a:effectRef idx="2">
+            <a:schemeClr val="accent1"/>
+          </a:effectRef>
+          <a:fontRef idx="minor">
+            <a:schemeClr val="lt1"/>
+          </a:fontRef>
+        </p:style>
+        <p:txBody>
+          <a:bodyPr rtlCol="0" anchor="ctr"/>
+          <a:lstStyle/>
+          <a:p>
+            <a:pPr algn="ctr"/>
+          </a:p>
+        </p:txBody>
+      </p:sp>
       <p:pic>
         <p:nvPicPr>
-          <p:cNvPr id="2" name="Picture 1" descr="deck-2.png"/>
+          <p:cNvPr id="7" name="Picture 6" descr="deck-glyphs-2.png"/>
           <p:cNvPicPr>
             <a:picLocks noChangeAspect="1"/>
           </p:cNvPicPr>
@@ -3716,6 +5300,843 @@
           </a:prstGeom>
         </p:spPr>
       </p:pic>
+      <p:sp>
+        <p:nvSpPr>
+          <p:cNvPr id="8" name="TextBox 7"/>
+          <p:cNvSpPr txBox="1"/>
+          <p:nvPr/>
+        </p:nvSpPr>
+        <p:spPr>
+          <a:xfrm>
+            <a:off x="444500" y="288032"/>
+            <a:ext cx="11493500" cy="195579"/>
+          </a:xfrm>
+          <a:prstGeom prst="rect">
+            <a:avLst/>
+          </a:prstGeom>
+          <a:noFill/>
+        </p:spPr>
+        <p:txBody>
+          <a:bodyPr wrap="none" lIns="0" rIns="0" tIns="0" bIns="0" anchor="t">
+            <a:spAutoFit/>
+          </a:bodyPr>
+          <a:lstStyle/>
+          <a:p>
+            <a:pPr algn="l">
+              <a:lnSpc>
+                <a:spcPct val="150000"/>
+              </a:lnSpc>
+            </a:pPr>
+            <a:r>
+              <a:rPr sz="980" b="0" spc="308">
+                <a:solidFill>
+                  <a:srgbClr val="6E6E73"/>
+                </a:solidFill>
+                <a:latin typeface="Helvetica Neue"/>
+              </a:rPr>
+              <a:t>NOT ON THE LIVE PATH</a:t>
+            </a:r>
+          </a:p>
+        </p:txBody>
+      </p:sp>
+      <p:sp>
+        <p:nvSpPr>
+          <p:cNvPr id="9" name="TextBox 8"/>
+          <p:cNvSpPr txBox="1"/>
+          <p:nvPr/>
+        </p:nvSpPr>
+        <p:spPr>
+          <a:xfrm>
+            <a:off x="444500" y="524470"/>
+            <a:ext cx="11493500" cy="640794"/>
+          </a:xfrm>
+          <a:prstGeom prst="rect">
+            <a:avLst/>
+          </a:prstGeom>
+          <a:noFill/>
+        </p:spPr>
+        <p:txBody>
+          <a:bodyPr wrap="none" lIns="0" rIns="0" tIns="0" bIns="0" anchor="t">
+            <a:spAutoFit/>
+          </a:bodyPr>
+          <a:lstStyle/>
+          <a:p>
+            <a:pPr algn="l">
+              <a:lnSpc>
+                <a:spcPct val="104000"/>
+              </a:lnSpc>
+            </a:pPr>
+            <a:r>
+              <a:rPr sz="4060" b="1" spc="-145">
+                <a:solidFill>
+                  <a:srgbClr val="1D1D1F"/>
+                </a:solidFill>
+                <a:latin typeface="Helvetica Neue"/>
+              </a:rPr>
+              <a:t>Built and </a:t>
+            </a:r>
+            <a:r>
+              <a:rPr sz="4060" b="1" spc="-145">
+                <a:solidFill>
+                  <a:srgbClr val="0071E3"/>
+                </a:solidFill>
+                <a:latin typeface="Helvetica Neue"/>
+              </a:rPr>
+              <a:t>checked</a:t>
+            </a:r>
+            <a:r>
+              <a:rPr sz="4060" b="1" spc="-145">
+                <a:solidFill>
+                  <a:srgbClr val="1D1D1F"/>
+                </a:solidFill>
+                <a:latin typeface="Helvetica Neue"/>
+              </a:rPr>
+              <a:t> by machines too.</a:t>
+            </a:r>
+          </a:p>
+        </p:txBody>
+      </p:sp>
+      <p:sp>
+        <p:nvSpPr>
+          <p:cNvPr id="10" name="TextBox 9"/>
+          <p:cNvSpPr txBox="1"/>
+          <p:nvPr/>
+        </p:nvSpPr>
+        <p:spPr>
+          <a:xfrm>
+            <a:off x="444500" y="974129"/>
+            <a:ext cx="11493500" cy="293370"/>
+          </a:xfrm>
+          <a:prstGeom prst="rect">
+            <a:avLst/>
+          </a:prstGeom>
+          <a:noFill/>
+        </p:spPr>
+        <p:txBody>
+          <a:bodyPr wrap="none" lIns="0" rIns="0" tIns="0" bIns="0" anchor="t">
+            <a:spAutoFit/>
+          </a:bodyPr>
+          <a:lstStyle/>
+          <a:p>
+            <a:pPr algn="l">
+              <a:lnSpc>
+                <a:spcPct val="150000"/>
+              </a:lnSpc>
+            </a:pPr>
+            <a:r>
+              <a:rPr sz="1470" b="0">
+                <a:solidFill>
+                  <a:srgbClr val="6E6E73"/>
+                </a:solidFill>
+                <a:latin typeface="Helvetica Neue"/>
+              </a:rPr>
+              <a:t>Whether to interrupt is plain code. Only her words go to a model — so only her words need evals.</a:t>
+            </a:r>
+          </a:p>
+        </p:txBody>
+      </p:sp>
+      <p:sp>
+        <p:nvSpPr>
+          <p:cNvPr id="11" name="TextBox 10"/>
+          <p:cNvSpPr txBox="1"/>
+          <p:nvPr/>
+        </p:nvSpPr>
+        <p:spPr>
+          <a:xfrm>
+            <a:off x="641350" y="2032496"/>
+            <a:ext cx="6550957" cy="349250"/>
+          </a:xfrm>
+          <a:prstGeom prst="rect">
+            <a:avLst/>
+          </a:prstGeom>
+          <a:noFill/>
+        </p:spPr>
+        <p:txBody>
+          <a:bodyPr wrap="none" lIns="0" rIns="0" tIns="0" bIns="0" anchor="t">
+            <a:spAutoFit/>
+          </a:bodyPr>
+          <a:lstStyle/>
+          <a:p>
+            <a:pPr algn="l">
+              <a:lnSpc>
+                <a:spcPct val="150000"/>
+              </a:lnSpc>
+            </a:pPr>
+            <a:r>
+              <a:rPr sz="1750" b="1" spc="-37">
+                <a:solidFill>
+                  <a:srgbClr val="1D1D1F"/>
+                </a:solidFill>
+                <a:latin typeface="Helvetica Neue"/>
+              </a:rPr>
+              <a:t>Devin</a:t>
+            </a:r>
+          </a:p>
+        </p:txBody>
+      </p:sp>
+      <p:sp>
+        <p:nvSpPr>
+          <p:cNvPr id="12" name="TextBox 11"/>
+          <p:cNvSpPr txBox="1"/>
+          <p:nvPr/>
+        </p:nvSpPr>
+        <p:spPr>
+          <a:xfrm>
+            <a:off x="641350" y="2373411"/>
+            <a:ext cx="6449357" cy="237490"/>
+          </a:xfrm>
+          <a:prstGeom prst="rect">
+            <a:avLst/>
+          </a:prstGeom>
+          <a:noFill/>
+        </p:spPr>
+        <p:txBody>
+          <a:bodyPr wrap="none" lIns="0" rIns="0" tIns="0" bIns="0" anchor="t">
+            <a:spAutoFit/>
+          </a:bodyPr>
+          <a:lstStyle/>
+          <a:p>
+            <a:pPr algn="l">
+              <a:lnSpc>
+                <a:spcPct val="150000"/>
+              </a:lnSpc>
+            </a:pPr>
+            <a:r>
+              <a:rPr sz="1190" b="0">
+                <a:solidFill>
+                  <a:srgbClr val="6E6E73"/>
+                </a:solidFill>
+                <a:latin typeface="Helvetica Neue"/>
+              </a:rPr>
+              <a:t>three PRs, all merged into main</a:t>
+            </a:r>
+          </a:p>
+        </p:txBody>
+      </p:sp>
+      <p:sp>
+        <p:nvSpPr>
+          <p:cNvPr id="13" name="TextBox 12"/>
+          <p:cNvSpPr txBox="1"/>
+          <p:nvPr/>
+        </p:nvSpPr>
+        <p:spPr>
+          <a:xfrm>
+            <a:off x="641350" y="2650827"/>
+            <a:ext cx="435897" cy="202565"/>
+          </a:xfrm>
+          <a:prstGeom prst="rect">
+            <a:avLst/>
+          </a:prstGeom>
+          <a:noFill/>
+        </p:spPr>
+        <p:txBody>
+          <a:bodyPr wrap="none" lIns="0" rIns="0" tIns="0" bIns="0" anchor="t">
+            <a:spAutoFit/>
+          </a:bodyPr>
+          <a:lstStyle/>
+          <a:p>
+            <a:pPr algn="l">
+              <a:lnSpc>
+                <a:spcPct val="150000"/>
+              </a:lnSpc>
+            </a:pPr>
+            <a:r>
+              <a:rPr sz="1190" b="1" spc="-25">
+                <a:solidFill>
+                  <a:srgbClr val="0071E3"/>
+                </a:solidFill>
+                <a:latin typeface="Helvetica Neue"/>
+              </a:rPr>
+              <a:t>#1</a:t>
+            </a:r>
+          </a:p>
+        </p:txBody>
+      </p:sp>
+      <p:sp>
+        <p:nvSpPr>
+          <p:cNvPr id="14" name="TextBox 13"/>
+          <p:cNvSpPr txBox="1"/>
+          <p:nvPr/>
+        </p:nvSpPr>
+        <p:spPr>
+          <a:xfrm>
+            <a:off x="641350" y="2806402"/>
+            <a:ext cx="6423957" cy="209550"/>
+          </a:xfrm>
+          <a:prstGeom prst="rect">
+            <a:avLst/>
+          </a:prstGeom>
+          <a:noFill/>
+        </p:spPr>
+        <p:txBody>
+          <a:bodyPr wrap="none" lIns="0" rIns="0" tIns="0" bIns="0" anchor="t">
+            <a:spAutoFit/>
+          </a:bodyPr>
+          <a:lstStyle/>
+          <a:p>
+            <a:pPr algn="l">
+              <a:lnSpc>
+                <a:spcPct val="150000"/>
+              </a:lnSpc>
+            </a:pPr>
+            <a:r>
+              <a:rPr sz="1050" b="0">
+                <a:solidFill>
+                  <a:srgbClr val="6E6E73"/>
+                </a:solidFill>
+                <a:latin typeface="Helvetica Neue"/>
+              </a:rPr>
+              <a:t>ten frozen cases, offline scorer, results table</a:t>
+            </a:r>
+          </a:p>
+        </p:txBody>
+      </p:sp>
+      <p:sp>
+        <p:nvSpPr>
+          <p:cNvPr id="15" name="TextBox 14"/>
+          <p:cNvSpPr txBox="1"/>
+          <p:nvPr/>
+        </p:nvSpPr>
+        <p:spPr>
+          <a:xfrm>
+            <a:off x="641350" y="3037383"/>
+            <a:ext cx="463609" cy="202565"/>
+          </a:xfrm>
+          <a:prstGeom prst="rect">
+            <a:avLst/>
+          </a:prstGeom>
+          <a:noFill/>
+        </p:spPr>
+        <p:txBody>
+          <a:bodyPr wrap="none" lIns="0" rIns="0" tIns="0" bIns="0" anchor="t">
+            <a:spAutoFit/>
+          </a:bodyPr>
+          <a:lstStyle/>
+          <a:p>
+            <a:pPr algn="l">
+              <a:lnSpc>
+                <a:spcPct val="150000"/>
+              </a:lnSpc>
+            </a:pPr>
+            <a:r>
+              <a:rPr sz="1190" b="1" spc="-25">
+                <a:solidFill>
+                  <a:srgbClr val="0071E3"/>
+                </a:solidFill>
+                <a:latin typeface="Helvetica Neue"/>
+              </a:rPr>
+              <a:t>#2</a:t>
+            </a:r>
+          </a:p>
+        </p:txBody>
+      </p:sp>
+      <p:sp>
+        <p:nvSpPr>
+          <p:cNvPr id="16" name="TextBox 15"/>
+          <p:cNvSpPr txBox="1"/>
+          <p:nvPr/>
+        </p:nvSpPr>
+        <p:spPr>
+          <a:xfrm>
+            <a:off x="641350" y="3192958"/>
+            <a:ext cx="6423957" cy="209550"/>
+          </a:xfrm>
+          <a:prstGeom prst="rect">
+            <a:avLst/>
+          </a:prstGeom>
+          <a:noFill/>
+        </p:spPr>
+        <p:txBody>
+          <a:bodyPr wrap="none" lIns="0" rIns="0" tIns="0" bIns="0" anchor="t">
+            <a:spAutoFit/>
+          </a:bodyPr>
+          <a:lstStyle/>
+          <a:p>
+            <a:pPr algn="l">
+              <a:lnSpc>
+                <a:spcPct val="150000"/>
+              </a:lnSpc>
+            </a:pPr>
+            <a:r>
+              <a:rPr sz="1050" b="0">
+                <a:solidFill>
+                  <a:srgbClr val="6E6E73"/>
+                </a:solidFill>
+                <a:latin typeface="Helvetica Neue"/>
+              </a:rPr>
+              <a:t>RRULE/RDATE/EXDATE expanded in the feed poller</a:t>
+            </a:r>
+          </a:p>
+        </p:txBody>
+      </p:sp>
+      <p:sp>
+        <p:nvSpPr>
+          <p:cNvPr id="17" name="TextBox 16"/>
+          <p:cNvSpPr txBox="1"/>
+          <p:nvPr/>
+        </p:nvSpPr>
+        <p:spPr>
+          <a:xfrm>
+            <a:off x="641350" y="3423939"/>
+            <a:ext cx="468699" cy="202565"/>
+          </a:xfrm>
+          <a:prstGeom prst="rect">
+            <a:avLst/>
+          </a:prstGeom>
+          <a:noFill/>
+        </p:spPr>
+        <p:txBody>
+          <a:bodyPr wrap="none" lIns="0" rIns="0" tIns="0" bIns="0" anchor="t">
+            <a:spAutoFit/>
+          </a:bodyPr>
+          <a:lstStyle/>
+          <a:p>
+            <a:pPr algn="l">
+              <a:lnSpc>
+                <a:spcPct val="150000"/>
+              </a:lnSpc>
+            </a:pPr>
+            <a:r>
+              <a:rPr sz="1190" b="1" spc="-25">
+                <a:solidFill>
+                  <a:srgbClr val="0071E3"/>
+                </a:solidFill>
+                <a:latin typeface="Helvetica Neue"/>
+              </a:rPr>
+              <a:t>#3</a:t>
+            </a:r>
+          </a:p>
+        </p:txBody>
+      </p:sp>
+      <p:sp>
+        <p:nvSpPr>
+          <p:cNvPr id="18" name="TextBox 17"/>
+          <p:cNvSpPr txBox="1"/>
+          <p:nvPr/>
+        </p:nvSpPr>
+        <p:spPr>
+          <a:xfrm>
+            <a:off x="641350" y="3579514"/>
+            <a:ext cx="6423957" cy="209550"/>
+          </a:xfrm>
+          <a:prstGeom prst="rect">
+            <a:avLst/>
+          </a:prstGeom>
+          <a:noFill/>
+        </p:spPr>
+        <p:txBody>
+          <a:bodyPr wrap="none" lIns="0" rIns="0" tIns="0" bIns="0" anchor="t">
+            <a:spAutoFit/>
+          </a:bodyPr>
+          <a:lstStyle/>
+          <a:p>
+            <a:pPr algn="l">
+              <a:lnSpc>
+                <a:spcPct val="150000"/>
+              </a:lnSpc>
+            </a:pPr>
+            <a:r>
+              <a:rPr sz="1050" b="0">
+                <a:solidFill>
+                  <a:srgbClr val="6E6E73"/>
+                </a:solidFill>
+                <a:latin typeface="Helvetica Neue"/>
+              </a:rPr>
+              <a:t>spoken chair lines fitted to the 20-word budget</a:t>
+            </a:r>
+          </a:p>
+        </p:txBody>
+      </p:sp>
+      <p:sp>
+        <p:nvSpPr>
+          <p:cNvPr id="19" name="TextBox 18"/>
+          <p:cNvSpPr txBox="1"/>
+          <p:nvPr/>
+        </p:nvSpPr>
+        <p:spPr>
+          <a:xfrm>
+            <a:off x="4455517" y="2032496"/>
+            <a:ext cx="6551146" cy="349250"/>
+          </a:xfrm>
+          <a:prstGeom prst="rect">
+            <a:avLst/>
+          </a:prstGeom>
+          <a:noFill/>
+        </p:spPr>
+        <p:txBody>
+          <a:bodyPr wrap="none" lIns="0" rIns="0" tIns="0" bIns="0" anchor="t">
+            <a:spAutoFit/>
+          </a:bodyPr>
+          <a:lstStyle/>
+          <a:p>
+            <a:pPr algn="l">
+              <a:lnSpc>
+                <a:spcPct val="150000"/>
+              </a:lnSpc>
+            </a:pPr>
+            <a:r>
+              <a:rPr sz="1750" b="1" spc="-37">
+                <a:solidFill>
+                  <a:srgbClr val="1D1D1F"/>
+                </a:solidFill>
+                <a:latin typeface="Helvetica Neue"/>
+              </a:rPr>
+              <a:t>Quality Clouds</a:t>
+            </a:r>
+          </a:p>
+        </p:txBody>
+      </p:sp>
+      <p:sp>
+        <p:nvSpPr>
+          <p:cNvPr id="20" name="TextBox 19"/>
+          <p:cNvSpPr txBox="1"/>
+          <p:nvPr/>
+        </p:nvSpPr>
+        <p:spPr>
+          <a:xfrm>
+            <a:off x="4455517" y="2373411"/>
+            <a:ext cx="6449546" cy="237490"/>
+          </a:xfrm>
+          <a:prstGeom prst="rect">
+            <a:avLst/>
+          </a:prstGeom>
+          <a:noFill/>
+        </p:spPr>
+        <p:txBody>
+          <a:bodyPr wrap="none" lIns="0" rIns="0" tIns="0" bIns="0" anchor="t">
+            <a:spAutoFit/>
+          </a:bodyPr>
+          <a:lstStyle/>
+          <a:p>
+            <a:pPr algn="l">
+              <a:lnSpc>
+                <a:spcPct val="150000"/>
+              </a:lnSpc>
+            </a:pPr>
+            <a:r>
+              <a:rPr sz="1190" b="0">
+                <a:solidFill>
+                  <a:srgbClr val="6E6E73"/>
+                </a:solidFill>
+                <a:latin typeface="Helvetica Neue"/>
+              </a:rPr>
+              <a:t>Norma scanned the repo</a:t>
+            </a:r>
+          </a:p>
+        </p:txBody>
+      </p:sp>
+      <p:sp>
+        <p:nvSpPr>
+          <p:cNvPr id="21" name="TextBox 20"/>
+          <p:cNvSpPr txBox="1"/>
+          <p:nvPr/>
+        </p:nvSpPr>
+        <p:spPr>
+          <a:xfrm>
+            <a:off x="4455517" y="2692896"/>
+            <a:ext cx="6462246" cy="251460"/>
+          </a:xfrm>
+          <a:prstGeom prst="rect">
+            <a:avLst/>
+          </a:prstGeom>
+          <a:noFill/>
+        </p:spPr>
+        <p:txBody>
+          <a:bodyPr wrap="none" lIns="0" rIns="0" tIns="0" bIns="0" anchor="t">
+            <a:spAutoFit/>
+          </a:bodyPr>
+          <a:lstStyle/>
+          <a:p>
+            <a:pPr algn="l">
+              <a:lnSpc>
+                <a:spcPct val="150000"/>
+              </a:lnSpc>
+            </a:pPr>
+            <a:r>
+              <a:rPr sz="1260" b="1">
+                <a:solidFill>
+                  <a:srgbClr val="087443"/>
+                </a:solidFill>
+                <a:latin typeface="Helvetica Neue"/>
+              </a:rPr>
+              <a:t>findings fixed</a:t>
+            </a:r>
+          </a:p>
+        </p:txBody>
+      </p:sp>
+      <p:sp>
+        <p:nvSpPr>
+          <p:cNvPr id="22" name="TextBox 21"/>
+          <p:cNvSpPr txBox="1"/>
+          <p:nvPr/>
+        </p:nvSpPr>
+        <p:spPr>
+          <a:xfrm>
+            <a:off x="4563467" y="3048892"/>
+            <a:ext cx="6026636" cy="223520"/>
+          </a:xfrm>
+          <a:prstGeom prst="rect">
+            <a:avLst/>
+          </a:prstGeom>
+          <a:noFill/>
+        </p:spPr>
+        <p:txBody>
+          <a:bodyPr wrap="none" lIns="0" rIns="0" tIns="0" bIns="0" anchor="t">
+            <a:spAutoFit/>
+          </a:bodyPr>
+          <a:lstStyle/>
+          <a:p>
+            <a:pPr algn="l">
+              <a:lnSpc>
+                <a:spcPct val="150000"/>
+              </a:lnSpc>
+            </a:pPr>
+            <a:r>
+              <a:rPr sz="1120" b="1" spc="16">
+                <a:solidFill>
+                  <a:srgbClr val="1D1D1F"/>
+                </a:solidFill>
+                <a:latin typeface="Helvetica Neue"/>
+              </a:rPr>
+              <a:t>What it improved</a:t>
+            </a:r>
+          </a:p>
+        </p:txBody>
+      </p:sp>
+      <p:sp>
+        <p:nvSpPr>
+          <p:cNvPr id="23" name="TextBox 22"/>
+          <p:cNvSpPr txBox="1"/>
+          <p:nvPr/>
+        </p:nvSpPr>
+        <p:spPr>
+          <a:xfrm>
+            <a:off x="4563467" y="3220342"/>
+            <a:ext cx="2260282" cy="185420"/>
+          </a:xfrm>
+          <a:prstGeom prst="rect">
+            <a:avLst/>
+          </a:prstGeom>
+          <a:noFill/>
+        </p:spPr>
+        <p:txBody>
+          <a:bodyPr wrap="none" lIns="0" rIns="0" tIns="0" bIns="0" anchor="t">
+            <a:spAutoFit/>
+          </a:bodyPr>
+          <a:lstStyle/>
+          <a:p>
+            <a:pPr algn="l">
+              <a:lnSpc>
+                <a:spcPct val="150000"/>
+              </a:lnSpc>
+            </a:pPr>
+            <a:r>
+              <a:rPr sz="1120" b="0">
+                <a:solidFill>
+                  <a:srgbClr val="B0B3BE"/>
+                </a:solidFill>
+                <a:latin typeface="Helvetica Neue"/>
+              </a:rPr>
+              <a:t>— fill in before the pitch</a:t>
+            </a:r>
+          </a:p>
+        </p:txBody>
+      </p:sp>
+      <p:sp>
+        <p:nvSpPr>
+          <p:cNvPr id="24" name="TextBox 23"/>
+          <p:cNvSpPr txBox="1"/>
+          <p:nvPr/>
+        </p:nvSpPr>
+        <p:spPr>
+          <a:xfrm>
+            <a:off x="8269783" y="2032496"/>
+            <a:ext cx="3668216" cy="349250"/>
+          </a:xfrm>
+          <a:prstGeom prst="rect">
+            <a:avLst/>
+          </a:prstGeom>
+          <a:noFill/>
+        </p:spPr>
+        <p:txBody>
+          <a:bodyPr wrap="none" lIns="0" rIns="0" tIns="0" bIns="0" anchor="t">
+            <a:spAutoFit/>
+          </a:bodyPr>
+          <a:lstStyle/>
+          <a:p>
+            <a:pPr algn="l">
+              <a:lnSpc>
+                <a:spcPct val="150000"/>
+              </a:lnSpc>
+            </a:pPr>
+            <a:r>
+              <a:rPr sz="1750" b="1" spc="-37">
+                <a:solidFill>
+                  <a:srgbClr val="1D1D1F"/>
+                </a:solidFill>
+                <a:latin typeface="Helvetica Neue"/>
+              </a:rPr>
+              <a:t>Galtea</a:t>
+            </a:r>
+          </a:p>
+        </p:txBody>
+      </p:sp>
+      <p:sp>
+        <p:nvSpPr>
+          <p:cNvPr id="25" name="TextBox 24"/>
+          <p:cNvSpPr txBox="1"/>
+          <p:nvPr/>
+        </p:nvSpPr>
+        <p:spPr>
+          <a:xfrm>
+            <a:off x="8269783" y="2373411"/>
+            <a:ext cx="3668216" cy="237490"/>
+          </a:xfrm>
+          <a:prstGeom prst="rect">
+            <a:avLst/>
+          </a:prstGeom>
+          <a:noFill/>
+        </p:spPr>
+        <p:txBody>
+          <a:bodyPr wrap="none" lIns="0" rIns="0" tIns="0" bIns="0" anchor="t">
+            <a:spAutoFit/>
+          </a:bodyPr>
+          <a:lstStyle/>
+          <a:p>
+            <a:pPr algn="l">
+              <a:lnSpc>
+                <a:spcPct val="150000"/>
+              </a:lnSpc>
+            </a:pPr>
+            <a:r>
+              <a:rPr sz="1190" b="0">
+                <a:solidFill>
+                  <a:srgbClr val="6E6E73"/>
+                </a:solidFill>
+                <a:latin typeface="Helvetica Neue"/>
+              </a:rPr>
+              <a:t>ten frozen cases, traces sent</a:t>
+            </a:r>
+          </a:p>
+        </p:txBody>
+      </p:sp>
+      <p:sp>
+        <p:nvSpPr>
+          <p:cNvPr id="26" name="TextBox 25"/>
+          <p:cNvSpPr txBox="1"/>
+          <p:nvPr/>
+        </p:nvSpPr>
+        <p:spPr>
+          <a:xfrm>
+            <a:off x="8269783" y="2692896"/>
+            <a:ext cx="3668216" cy="251460"/>
+          </a:xfrm>
+          <a:prstGeom prst="rect">
+            <a:avLst/>
+          </a:prstGeom>
+          <a:noFill/>
+        </p:spPr>
+        <p:txBody>
+          <a:bodyPr wrap="none" lIns="0" rIns="0" tIns="0" bIns="0" anchor="t">
+            <a:spAutoFit/>
+          </a:bodyPr>
+          <a:lstStyle/>
+          <a:p>
+            <a:pPr algn="l">
+              <a:lnSpc>
+                <a:spcPct val="150000"/>
+              </a:lnSpc>
+            </a:pPr>
+            <a:r>
+              <a:rPr sz="1260" b="1">
+                <a:solidFill>
+                  <a:srgbClr val="087443"/>
+                </a:solidFill>
+                <a:latin typeface="Helvetica Neue"/>
+              </a:rPr>
+              <a:t>scored, 5 dimensions</a:t>
+            </a:r>
+          </a:p>
+        </p:txBody>
+      </p:sp>
+      <p:sp>
+        <p:nvSpPr>
+          <p:cNvPr id="27" name="TextBox 26"/>
+          <p:cNvSpPr txBox="1"/>
+          <p:nvPr/>
+        </p:nvSpPr>
+        <p:spPr>
+          <a:xfrm>
+            <a:off x="8377733" y="3048892"/>
+            <a:ext cx="3560266" cy="223520"/>
+          </a:xfrm>
+          <a:prstGeom prst="rect">
+            <a:avLst/>
+          </a:prstGeom>
+          <a:noFill/>
+        </p:spPr>
+        <p:txBody>
+          <a:bodyPr wrap="none" lIns="0" rIns="0" tIns="0" bIns="0" anchor="t">
+            <a:spAutoFit/>
+          </a:bodyPr>
+          <a:lstStyle/>
+          <a:p>
+            <a:pPr algn="l">
+              <a:lnSpc>
+                <a:spcPct val="150000"/>
+              </a:lnSpc>
+            </a:pPr>
+            <a:r>
+              <a:rPr sz="1120" b="1" spc="16">
+                <a:solidFill>
+                  <a:srgbClr val="1D1D1F"/>
+                </a:solidFill>
+                <a:latin typeface="Helvetica Neue"/>
+              </a:rPr>
+              <a:t>What it improved</a:t>
+            </a:r>
+          </a:p>
+        </p:txBody>
+      </p:sp>
+      <p:sp>
+        <p:nvSpPr>
+          <p:cNvPr id="28" name="TextBox 27"/>
+          <p:cNvSpPr txBox="1"/>
+          <p:nvPr/>
+        </p:nvSpPr>
+        <p:spPr>
+          <a:xfrm>
+            <a:off x="8377733" y="3220342"/>
+            <a:ext cx="2260282" cy="185420"/>
+          </a:xfrm>
+          <a:prstGeom prst="rect">
+            <a:avLst/>
+          </a:prstGeom>
+          <a:noFill/>
+        </p:spPr>
+        <p:txBody>
+          <a:bodyPr wrap="none" lIns="0" rIns="0" tIns="0" bIns="0" anchor="t">
+            <a:spAutoFit/>
+          </a:bodyPr>
+          <a:lstStyle/>
+          <a:p>
+            <a:pPr algn="l">
+              <a:lnSpc>
+                <a:spcPct val="150000"/>
+              </a:lnSpc>
+            </a:pPr>
+            <a:r>
+              <a:rPr sz="1120" b="0">
+                <a:solidFill>
+                  <a:srgbClr val="B0B3BE"/>
+                </a:solidFill>
+                <a:latin typeface="Helvetica Neue"/>
+              </a:rPr>
+              <a:t>— fill in before the pitch</a:t>
+            </a:r>
+          </a:p>
+        </p:txBody>
+      </p:sp>
     </p:spTree>
   </p:cSld>
   <p:clrMapOvr>
@@ -3727,6 +6148,14 @@
 <file path=ppt/slides/slide3.xml><?xml version="1.0" encoding="utf-8"?>
 <p:sld xmlns:a="http://schemas.openxmlformats.org/drawingml/2006/main" xmlns:p="http://schemas.openxmlformats.org/presentationml/2006/main" xmlns:r="http://schemas.openxmlformats.org/officeDocument/2006/relationships">
   <p:cSld>
+    <p:bg>
+      <p:bgPr>
+        <a:solidFill>
+          <a:srgbClr val="FBFBFD"/>
+        </a:solidFill>
+        <a:effectLst/>
+      </p:bgPr>
+    </p:bg>
     <p:spTree>
       <p:nvGrpSpPr>
         <p:cNvPr id="1" name=""/>
@@ -3734,9 +6163,417 @@
         <p:nvPr/>
       </p:nvGrpSpPr>
       <p:grpSpPr/>
+      <p:sp>
+        <p:nvSpPr>
+          <p:cNvPr id="2" name="Rounded Rectangle 1"/>
+          <p:cNvSpPr/>
+          <p:nvPr/>
+        </p:nvSpPr>
+        <p:spPr>
+          <a:xfrm>
+            <a:off x="444500" y="1324967"/>
+            <a:ext cx="3475632" cy="4304407"/>
+          </a:xfrm>
+          <a:prstGeom prst="roundRect">
+            <a:avLst>
+              <a:gd name="adj" fmla="val 3654"/>
+            </a:avLst>
+          </a:prstGeom>
+          <a:solidFill>
+            <a:srgbClr val="FFFFFF"/>
+          </a:solidFill>
+          <a:ln w="9525">
+            <a:solidFill>
+              <a:srgbClr val="C9DCEE"/>
+            </a:solidFill>
+          </a:ln>
+          <a:effectLst/>
+        </p:spPr>
+        <p:style>
+          <a:lnRef idx="1">
+            <a:schemeClr val="accent1"/>
+          </a:lnRef>
+          <a:fillRef idx="3">
+            <a:schemeClr val="accent1"/>
+          </a:fillRef>
+          <a:effectRef idx="2">
+            <a:schemeClr val="accent1"/>
+          </a:effectRef>
+          <a:fontRef idx="minor">
+            <a:schemeClr val="lt1"/>
+          </a:fontRef>
+        </p:style>
+        <p:txBody>
+          <a:bodyPr rtlCol="0" anchor="ctr"/>
+          <a:lstStyle/>
+          <a:p>
+            <a:pPr algn="ctr"/>
+          </a:p>
+        </p:txBody>
+      </p:sp>
+      <p:sp>
+        <p:nvSpPr>
+          <p:cNvPr id="3" name="Rounded Rectangle 2"/>
+          <p:cNvSpPr/>
+          <p:nvPr/>
+        </p:nvSpPr>
+        <p:spPr>
+          <a:xfrm>
+            <a:off x="641350" y="1830685"/>
+            <a:ext cx="3081932" cy="425450"/>
+          </a:xfrm>
+          <a:prstGeom prst="roundRect">
+            <a:avLst>
+              <a:gd name="adj" fmla="val 0"/>
+            </a:avLst>
+          </a:prstGeom>
+          <a:noFill/>
+          <a:ln>
+            <a:noFill/>
+          </a:ln>
+          <a:effectLst/>
+        </p:spPr>
+        <p:style>
+          <a:lnRef idx="1">
+            <a:schemeClr val="accent1"/>
+          </a:lnRef>
+          <a:fillRef idx="3">
+            <a:schemeClr val="accent1"/>
+          </a:fillRef>
+          <a:effectRef idx="2">
+            <a:schemeClr val="accent1"/>
+          </a:effectRef>
+          <a:fontRef idx="minor">
+            <a:schemeClr val="lt1"/>
+          </a:fontRef>
+        </p:style>
+        <p:txBody>
+          <a:bodyPr rtlCol="0" anchor="ctr"/>
+          <a:lstStyle/>
+          <a:p>
+            <a:pPr algn="ctr"/>
+          </a:p>
+        </p:txBody>
+      </p:sp>
+      <p:sp>
+        <p:nvSpPr>
+          <p:cNvPr id="4" name="Rounded Rectangle 3"/>
+          <p:cNvSpPr/>
+          <p:nvPr/>
+        </p:nvSpPr>
+        <p:spPr>
+          <a:xfrm>
+            <a:off x="4358183" y="1324967"/>
+            <a:ext cx="3475632" cy="4304407"/>
+          </a:xfrm>
+          <a:prstGeom prst="roundRect">
+            <a:avLst>
+              <a:gd name="adj" fmla="val 3654"/>
+            </a:avLst>
+          </a:prstGeom>
+          <a:solidFill>
+            <a:srgbClr val="FFFFFF"/>
+          </a:solidFill>
+          <a:ln w="9525">
+            <a:solidFill>
+              <a:srgbClr val="E4E4EA"/>
+            </a:solidFill>
+          </a:ln>
+          <a:effectLst/>
+        </p:spPr>
+        <p:style>
+          <a:lnRef idx="1">
+            <a:schemeClr val="accent1"/>
+          </a:lnRef>
+          <a:fillRef idx="3">
+            <a:schemeClr val="accent1"/>
+          </a:fillRef>
+          <a:effectRef idx="2">
+            <a:schemeClr val="accent1"/>
+          </a:effectRef>
+          <a:fontRef idx="minor">
+            <a:schemeClr val="lt1"/>
+          </a:fontRef>
+        </p:style>
+        <p:txBody>
+          <a:bodyPr rtlCol="0" anchor="ctr"/>
+          <a:lstStyle/>
+          <a:p>
+            <a:pPr algn="ctr"/>
+          </a:p>
+        </p:txBody>
+      </p:sp>
+      <p:sp>
+        <p:nvSpPr>
+          <p:cNvPr id="5" name="Rounded Rectangle 4"/>
+          <p:cNvSpPr/>
+          <p:nvPr/>
+        </p:nvSpPr>
+        <p:spPr>
+          <a:xfrm>
+            <a:off x="4555033" y="1830685"/>
+            <a:ext cx="3081932" cy="425450"/>
+          </a:xfrm>
+          <a:prstGeom prst="roundRect">
+            <a:avLst>
+              <a:gd name="adj" fmla="val 0"/>
+            </a:avLst>
+          </a:prstGeom>
+          <a:noFill/>
+          <a:ln>
+            <a:noFill/>
+          </a:ln>
+          <a:effectLst/>
+        </p:spPr>
+        <p:style>
+          <a:lnRef idx="1">
+            <a:schemeClr val="accent1"/>
+          </a:lnRef>
+          <a:fillRef idx="3">
+            <a:schemeClr val="accent1"/>
+          </a:fillRef>
+          <a:effectRef idx="2">
+            <a:schemeClr val="accent1"/>
+          </a:effectRef>
+          <a:fontRef idx="minor">
+            <a:schemeClr val="lt1"/>
+          </a:fontRef>
+        </p:style>
+        <p:txBody>
+          <a:bodyPr rtlCol="0" anchor="ctr"/>
+          <a:lstStyle/>
+          <a:p>
+            <a:pPr algn="ctr"/>
+          </a:p>
+        </p:txBody>
+      </p:sp>
+      <p:sp>
+        <p:nvSpPr>
+          <p:cNvPr id="6" name="Rounded Rectangle 5"/>
+          <p:cNvSpPr/>
+          <p:nvPr/>
+        </p:nvSpPr>
+        <p:spPr>
+          <a:xfrm>
+            <a:off x="4555033" y="2338387"/>
+            <a:ext cx="3081932" cy="425450"/>
+          </a:xfrm>
+          <a:prstGeom prst="roundRect">
+            <a:avLst>
+              <a:gd name="adj" fmla="val 0"/>
+            </a:avLst>
+          </a:prstGeom>
+          <a:noFill/>
+          <a:ln>
+            <a:noFill/>
+          </a:ln>
+          <a:effectLst/>
+        </p:spPr>
+        <p:style>
+          <a:lnRef idx="1">
+            <a:schemeClr val="accent1"/>
+          </a:lnRef>
+          <a:fillRef idx="3">
+            <a:schemeClr val="accent1"/>
+          </a:fillRef>
+          <a:effectRef idx="2">
+            <a:schemeClr val="accent1"/>
+          </a:effectRef>
+          <a:fontRef idx="minor">
+            <a:schemeClr val="lt1"/>
+          </a:fontRef>
+        </p:style>
+        <p:txBody>
+          <a:bodyPr rtlCol="0" anchor="ctr"/>
+          <a:lstStyle/>
+          <a:p>
+            <a:pPr algn="ctr"/>
+          </a:p>
+        </p:txBody>
+      </p:sp>
+      <p:sp>
+        <p:nvSpPr>
+          <p:cNvPr id="7" name="Rounded Rectangle 6"/>
+          <p:cNvSpPr/>
+          <p:nvPr/>
+        </p:nvSpPr>
+        <p:spPr>
+          <a:xfrm>
+            <a:off x="8271867" y="1324967"/>
+            <a:ext cx="3475632" cy="4304407"/>
+          </a:xfrm>
+          <a:prstGeom prst="roundRect">
+            <a:avLst>
+              <a:gd name="adj" fmla="val 3654"/>
+            </a:avLst>
+          </a:prstGeom>
+          <a:solidFill>
+            <a:srgbClr val="FFFFFF"/>
+          </a:solidFill>
+          <a:ln w="9525">
+            <a:solidFill>
+              <a:srgbClr val="E4E4EA"/>
+            </a:solidFill>
+          </a:ln>
+          <a:effectLst/>
+        </p:spPr>
+        <p:style>
+          <a:lnRef idx="1">
+            <a:schemeClr val="accent1"/>
+          </a:lnRef>
+          <a:fillRef idx="3">
+            <a:schemeClr val="accent1"/>
+          </a:fillRef>
+          <a:effectRef idx="2">
+            <a:schemeClr val="accent1"/>
+          </a:effectRef>
+          <a:fontRef idx="minor">
+            <a:schemeClr val="lt1"/>
+          </a:fontRef>
+        </p:style>
+        <p:txBody>
+          <a:bodyPr rtlCol="0" anchor="ctr"/>
+          <a:lstStyle/>
+          <a:p>
+            <a:pPr algn="ctr"/>
+          </a:p>
+        </p:txBody>
+      </p:sp>
+      <p:sp>
+        <p:nvSpPr>
+          <p:cNvPr id="8" name="Rounded Rectangle 7"/>
+          <p:cNvSpPr/>
+          <p:nvPr/>
+        </p:nvSpPr>
+        <p:spPr>
+          <a:xfrm>
+            <a:off x="8468717" y="1830685"/>
+            <a:ext cx="3081932" cy="425450"/>
+          </a:xfrm>
+          <a:prstGeom prst="roundRect">
+            <a:avLst>
+              <a:gd name="adj" fmla="val 0"/>
+            </a:avLst>
+          </a:prstGeom>
+          <a:noFill/>
+          <a:ln>
+            <a:noFill/>
+          </a:ln>
+          <a:effectLst/>
+        </p:spPr>
+        <p:style>
+          <a:lnRef idx="1">
+            <a:schemeClr val="accent1"/>
+          </a:lnRef>
+          <a:fillRef idx="3">
+            <a:schemeClr val="accent1"/>
+          </a:fillRef>
+          <a:effectRef idx="2">
+            <a:schemeClr val="accent1"/>
+          </a:effectRef>
+          <a:fontRef idx="minor">
+            <a:schemeClr val="lt1"/>
+          </a:fontRef>
+        </p:style>
+        <p:txBody>
+          <a:bodyPr rtlCol="0" anchor="ctr"/>
+          <a:lstStyle/>
+          <a:p>
+            <a:pPr algn="ctr"/>
+          </a:p>
+        </p:txBody>
+      </p:sp>
+      <p:sp>
+        <p:nvSpPr>
+          <p:cNvPr id="9" name="Rounded Rectangle 8"/>
+          <p:cNvSpPr/>
+          <p:nvPr/>
+        </p:nvSpPr>
+        <p:spPr>
+          <a:xfrm>
+            <a:off x="8468717" y="2338387"/>
+            <a:ext cx="3081932" cy="425450"/>
+          </a:xfrm>
+          <a:prstGeom prst="roundRect">
+            <a:avLst>
+              <a:gd name="adj" fmla="val 0"/>
+            </a:avLst>
+          </a:prstGeom>
+          <a:noFill/>
+          <a:ln>
+            <a:noFill/>
+          </a:ln>
+          <a:effectLst/>
+        </p:spPr>
+        <p:style>
+          <a:lnRef idx="1">
+            <a:schemeClr val="accent1"/>
+          </a:lnRef>
+          <a:fillRef idx="3">
+            <a:schemeClr val="accent1"/>
+          </a:fillRef>
+          <a:effectRef idx="2">
+            <a:schemeClr val="accent1"/>
+          </a:effectRef>
+          <a:fontRef idx="minor">
+            <a:schemeClr val="lt1"/>
+          </a:fontRef>
+        </p:style>
+        <p:txBody>
+          <a:bodyPr rtlCol="0" anchor="ctr"/>
+          <a:lstStyle/>
+          <a:p>
+            <a:pPr algn="ctr"/>
+          </a:p>
+        </p:txBody>
+      </p:sp>
+      <p:sp>
+        <p:nvSpPr>
+          <p:cNvPr id="10" name="Rounded Rectangle 9"/>
+          <p:cNvSpPr/>
+          <p:nvPr/>
+        </p:nvSpPr>
+        <p:spPr>
+          <a:xfrm>
+            <a:off x="8468717" y="2846089"/>
+            <a:ext cx="3081932" cy="596900"/>
+          </a:xfrm>
+          <a:prstGeom prst="roundRect">
+            <a:avLst>
+              <a:gd name="adj" fmla="val 0"/>
+            </a:avLst>
+          </a:prstGeom>
+          <a:noFill/>
+          <a:ln>
+            <a:noFill/>
+          </a:ln>
+          <a:effectLst/>
+        </p:spPr>
+        <p:style>
+          <a:lnRef idx="1">
+            <a:schemeClr val="accent1"/>
+          </a:lnRef>
+          <a:fillRef idx="3">
+            <a:schemeClr val="accent1"/>
+          </a:fillRef>
+          <a:effectRef idx="2">
+            <a:schemeClr val="accent1"/>
+          </a:effectRef>
+          <a:fontRef idx="minor">
+            <a:schemeClr val="lt1"/>
+          </a:fontRef>
+        </p:style>
+        <p:txBody>
+          <a:bodyPr rtlCol="0" anchor="ctr"/>
+          <a:lstStyle/>
+          <a:p>
+            <a:pPr algn="ctr"/>
+          </a:p>
+        </p:txBody>
+      </p:sp>
       <p:pic>
         <p:nvPicPr>
-          <p:cNvPr id="2" name="Picture 1" descr="deck-3.png"/>
+          <p:cNvPr id="11" name="Picture 10" descr="deck-glyphs-3.png"/>
           <p:cNvPicPr>
             <a:picLocks noChangeAspect="1"/>
           </p:cNvPicPr>
@@ -3758,6 +6595,900 @@
           </a:prstGeom>
         </p:spPr>
       </p:pic>
+      <p:sp>
+        <p:nvSpPr>
+          <p:cNvPr id="12" name="TextBox 11"/>
+          <p:cNvSpPr txBox="1"/>
+          <p:nvPr/>
+        </p:nvSpPr>
+        <p:spPr>
+          <a:xfrm>
+            <a:off x="444500" y="288032"/>
+            <a:ext cx="11493500" cy="195579"/>
+          </a:xfrm>
+          <a:prstGeom prst="rect">
+            <a:avLst/>
+          </a:prstGeom>
+          <a:noFill/>
+        </p:spPr>
+        <p:txBody>
+          <a:bodyPr wrap="none" lIns="0" rIns="0" tIns="0" bIns="0" anchor="t">
+            <a:spAutoFit/>
+          </a:bodyPr>
+          <a:lstStyle/>
+          <a:p>
+            <a:pPr algn="l">
+              <a:lnSpc>
+                <a:spcPct val="150000"/>
+              </a:lnSpc>
+            </a:pPr>
+            <a:r>
+              <a:rPr sz="980" b="0" spc="308">
+                <a:solidFill>
+                  <a:srgbClr val="6E6E73"/>
+                </a:solidFill>
+                <a:latin typeface="Helvetica Neue"/>
+              </a:rPr>
+              <a:t>WHERE THIS GOES</a:t>
+            </a:r>
+          </a:p>
+        </p:txBody>
+      </p:sp>
+      <p:sp>
+        <p:nvSpPr>
+          <p:cNvPr id="13" name="TextBox 12"/>
+          <p:cNvSpPr txBox="1"/>
+          <p:nvPr/>
+        </p:nvSpPr>
+        <p:spPr>
+          <a:xfrm>
+            <a:off x="444500" y="524470"/>
+            <a:ext cx="11493500" cy="640794"/>
+          </a:xfrm>
+          <a:prstGeom prst="rect">
+            <a:avLst/>
+          </a:prstGeom>
+          <a:noFill/>
+        </p:spPr>
+        <p:txBody>
+          <a:bodyPr wrap="none" lIns="0" rIns="0" tIns="0" bIns="0" anchor="t">
+            <a:spAutoFit/>
+          </a:bodyPr>
+          <a:lstStyle/>
+          <a:p>
+            <a:pPr algn="l">
+              <a:lnSpc>
+                <a:spcPct val="104000"/>
+              </a:lnSpc>
+            </a:pPr>
+            <a:r>
+              <a:rPr sz="4060" b="1" spc="-145">
+                <a:solidFill>
+                  <a:srgbClr val="1D1D1F"/>
+                </a:solidFill>
+                <a:latin typeface="Helvetica Neue"/>
+              </a:rPr>
+              <a:t>Discord was the </a:t>
+            </a:r>
+            <a:r>
+              <a:rPr sz="4060" b="1" spc="-145">
+                <a:solidFill>
+                  <a:srgbClr val="0071E3"/>
+                </a:solidFill>
+                <a:latin typeface="Helvetica Neue"/>
+              </a:rPr>
+              <a:t>demo</a:t>
+            </a:r>
+            <a:r>
+              <a:rPr sz="4060" b="1" spc="-145">
+                <a:solidFill>
+                  <a:srgbClr val="1D1D1F"/>
+                </a:solidFill>
+                <a:latin typeface="Helvetica Neue"/>
+              </a:rPr>
+              <a:t>. Teams is the </a:t>
+            </a:r>
+            <a:r>
+              <a:rPr sz="4060" b="1" spc="-145">
+                <a:solidFill>
+                  <a:srgbClr val="0071E3"/>
+                </a:solidFill>
+                <a:latin typeface="Helvetica Neue"/>
+              </a:rPr>
+              <a:t>product</a:t>
+            </a:r>
+            <a:r>
+              <a:rPr sz="4060" b="1" spc="-145">
+                <a:solidFill>
+                  <a:srgbClr val="1D1D1F"/>
+                </a:solidFill>
+                <a:latin typeface="Helvetica Neue"/>
+              </a:rPr>
+              <a:t>.</a:t>
+            </a:r>
+          </a:p>
+        </p:txBody>
+      </p:sp>
+      <p:sp>
+        <p:nvSpPr>
+          <p:cNvPr id="14" name="TextBox 13"/>
+          <p:cNvSpPr txBox="1"/>
+          <p:nvPr/>
+        </p:nvSpPr>
+        <p:spPr>
+          <a:xfrm>
+            <a:off x="444500" y="974129"/>
+            <a:ext cx="11493500" cy="293370"/>
+          </a:xfrm>
+          <a:prstGeom prst="rect">
+            <a:avLst/>
+          </a:prstGeom>
+          <a:noFill/>
+        </p:spPr>
+        <p:txBody>
+          <a:bodyPr wrap="none" lIns="0" rIns="0" tIns="0" bIns="0" anchor="t">
+            <a:spAutoFit/>
+          </a:bodyPr>
+          <a:lstStyle/>
+          <a:p>
+            <a:pPr algn="l">
+              <a:lnSpc>
+                <a:spcPct val="150000"/>
+              </a:lnSpc>
+            </a:pPr>
+            <a:r>
+              <a:rPr sz="1470" b="0">
+                <a:solidFill>
+                  <a:srgbClr val="6E6E73"/>
+                </a:solidFill>
+                <a:latin typeface="Helvetica Neue"/>
+              </a:rPr>
+              <a:t>One container knows what a voice call is. Everything else already doesn't care.</a:t>
+            </a:r>
+          </a:p>
+        </p:txBody>
+      </p:sp>
+      <p:sp>
+        <p:nvSpPr>
+          <p:cNvPr id="15" name="TextBox 14"/>
+          <p:cNvSpPr txBox="1"/>
+          <p:nvPr/>
+        </p:nvSpPr>
+        <p:spPr>
+          <a:xfrm>
+            <a:off x="641350" y="1523305"/>
+            <a:ext cx="6046172" cy="209550"/>
+          </a:xfrm>
+          <a:prstGeom prst="rect">
+            <a:avLst/>
+          </a:prstGeom>
+          <a:noFill/>
+        </p:spPr>
+        <p:txBody>
+          <a:bodyPr wrap="none" lIns="0" rIns="0" tIns="0" bIns="0" anchor="t">
+            <a:spAutoFit/>
+          </a:bodyPr>
+          <a:lstStyle/>
+          <a:p>
+            <a:pPr algn="l">
+              <a:lnSpc>
+                <a:spcPct val="150000"/>
+              </a:lnSpc>
+            </a:pPr>
+            <a:r>
+              <a:rPr sz="1050" b="0" spc="300">
+                <a:solidFill>
+                  <a:srgbClr val="087443"/>
+                </a:solidFill>
+                <a:latin typeface="Helvetica Neue"/>
+              </a:rPr>
+              <a:t>NOW</a:t>
+            </a:r>
+          </a:p>
+        </p:txBody>
+      </p:sp>
+      <p:sp>
+        <p:nvSpPr>
+          <p:cNvPr id="16" name="TextBox 15"/>
+          <p:cNvSpPr txBox="1"/>
+          <p:nvPr/>
+        </p:nvSpPr>
+        <p:spPr>
+          <a:xfrm>
+            <a:off x="1085850" y="1830685"/>
+            <a:ext cx="1744255" cy="363220"/>
+          </a:xfrm>
+          <a:prstGeom prst="rect">
+            <a:avLst/>
+          </a:prstGeom>
+          <a:noFill/>
+        </p:spPr>
+        <p:txBody>
+          <a:bodyPr wrap="none" lIns="0" rIns="0" tIns="0" bIns="0" anchor="t">
+            <a:spAutoFit/>
+          </a:bodyPr>
+          <a:lstStyle/>
+          <a:p>
+            <a:pPr algn="l">
+              <a:lnSpc>
+                <a:spcPct val="150000"/>
+              </a:lnSpc>
+            </a:pPr>
+            <a:r>
+              <a:rPr sz="1820" b="1" spc="-26">
+                <a:solidFill>
+                  <a:srgbClr val="1D1D1F"/>
+                </a:solidFill>
+                <a:latin typeface="Helvetica Neue"/>
+              </a:rPr>
+              <a:t>Discord</a:t>
+            </a:r>
+          </a:p>
+        </p:txBody>
+      </p:sp>
+      <p:sp>
+        <p:nvSpPr>
+          <p:cNvPr id="17" name="TextBox 16"/>
+          <p:cNvSpPr txBox="1"/>
+          <p:nvPr/>
+        </p:nvSpPr>
+        <p:spPr>
+          <a:xfrm>
+            <a:off x="1085850" y="2084685"/>
+            <a:ext cx="1642655" cy="251460"/>
+          </a:xfrm>
+          <a:prstGeom prst="rect">
+            <a:avLst/>
+          </a:prstGeom>
+          <a:noFill/>
+        </p:spPr>
+        <p:txBody>
+          <a:bodyPr wrap="none" lIns="0" rIns="0" tIns="0" bIns="0" anchor="t">
+            <a:spAutoFit/>
+          </a:bodyPr>
+          <a:lstStyle/>
+          <a:p>
+            <a:pPr algn="l">
+              <a:lnSpc>
+                <a:spcPct val="150000"/>
+              </a:lnSpc>
+            </a:pPr>
+            <a:r>
+              <a:rPr sz="1260" b="0" spc="36">
+                <a:solidFill>
+                  <a:srgbClr val="6E6E73"/>
+                </a:solidFill>
+                <a:latin typeface="Helvetica Neue"/>
+              </a:rPr>
+              <a:t>one room, live</a:t>
+            </a:r>
+          </a:p>
+        </p:txBody>
+      </p:sp>
+      <p:sp>
+        <p:nvSpPr>
+          <p:cNvPr id="18" name="TextBox 17"/>
+          <p:cNvSpPr txBox="1"/>
+          <p:nvPr/>
+        </p:nvSpPr>
+        <p:spPr>
+          <a:xfrm>
+            <a:off x="4034432" y="3362821"/>
+            <a:ext cx="855156" cy="388620"/>
+          </a:xfrm>
+          <a:prstGeom prst="rect">
+            <a:avLst/>
+          </a:prstGeom>
+          <a:noFill/>
+        </p:spPr>
+        <p:txBody>
+          <a:bodyPr wrap="none" lIns="0" rIns="0" tIns="0" bIns="0" anchor="t">
+            <a:spAutoFit/>
+          </a:bodyPr>
+          <a:lstStyle/>
+          <a:p>
+            <a:pPr algn="l">
+              <a:lnSpc>
+                <a:spcPct val="100000"/>
+              </a:lnSpc>
+            </a:pPr>
+            <a:r>
+              <a:rPr sz="2520" b="0">
+                <a:solidFill>
+                  <a:srgbClr val="C2C6D2"/>
+                </a:solidFill>
+                <a:latin typeface="Helvetica Neue"/>
+              </a:rPr>
+              <a:t>→</a:t>
+            </a:r>
+          </a:p>
+        </p:txBody>
+      </p:sp>
+      <p:sp>
+        <p:nvSpPr>
+          <p:cNvPr id="19" name="TextBox 18"/>
+          <p:cNvSpPr txBox="1"/>
+          <p:nvPr/>
+        </p:nvSpPr>
+        <p:spPr>
+          <a:xfrm>
+            <a:off x="4555033" y="1523305"/>
+            <a:ext cx="6046172" cy="209550"/>
+          </a:xfrm>
+          <a:prstGeom prst="rect">
+            <a:avLst/>
+          </a:prstGeom>
+          <a:noFill/>
+        </p:spPr>
+        <p:txBody>
+          <a:bodyPr wrap="none" lIns="0" rIns="0" tIns="0" bIns="0" anchor="t">
+            <a:spAutoFit/>
+          </a:bodyPr>
+          <a:lstStyle/>
+          <a:p>
+            <a:pPr algn="l">
+              <a:lnSpc>
+                <a:spcPct val="150000"/>
+              </a:lnSpc>
+            </a:pPr>
+            <a:r>
+              <a:rPr sz="1050" b="0" spc="300">
+                <a:solidFill>
+                  <a:srgbClr val="0071E3"/>
+                </a:solidFill>
+                <a:latin typeface="Helvetica Neue"/>
+              </a:rPr>
+              <a:t>NEXT</a:t>
+            </a:r>
+          </a:p>
+        </p:txBody>
+      </p:sp>
+      <p:sp>
+        <p:nvSpPr>
+          <p:cNvPr id="20" name="TextBox 19"/>
+          <p:cNvSpPr txBox="1"/>
+          <p:nvPr/>
+        </p:nvSpPr>
+        <p:spPr>
+          <a:xfrm>
+            <a:off x="4999533" y="1830685"/>
+            <a:ext cx="2115065" cy="363220"/>
+          </a:xfrm>
+          <a:prstGeom prst="rect">
+            <a:avLst/>
+          </a:prstGeom>
+          <a:noFill/>
+        </p:spPr>
+        <p:txBody>
+          <a:bodyPr wrap="none" lIns="0" rIns="0" tIns="0" bIns="0" anchor="t">
+            <a:spAutoFit/>
+          </a:bodyPr>
+          <a:lstStyle/>
+          <a:p>
+            <a:pPr algn="l">
+              <a:lnSpc>
+                <a:spcPct val="150000"/>
+              </a:lnSpc>
+            </a:pPr>
+            <a:r>
+              <a:rPr sz="1820" b="1" spc="-26">
+                <a:solidFill>
+                  <a:srgbClr val="1D1D1F"/>
+                </a:solidFill>
+                <a:latin typeface="Helvetica Neue"/>
+              </a:rPr>
+              <a:t>Google Meet</a:t>
+            </a:r>
+          </a:p>
+        </p:txBody>
+      </p:sp>
+      <p:sp>
+        <p:nvSpPr>
+          <p:cNvPr id="21" name="TextBox 20"/>
+          <p:cNvSpPr txBox="1"/>
+          <p:nvPr/>
+        </p:nvSpPr>
+        <p:spPr>
+          <a:xfrm>
+            <a:off x="4999533" y="2084685"/>
+            <a:ext cx="2013465" cy="251460"/>
+          </a:xfrm>
+          <a:prstGeom prst="rect">
+            <a:avLst/>
+          </a:prstGeom>
+          <a:noFill/>
+        </p:spPr>
+        <p:txBody>
+          <a:bodyPr wrap="none" lIns="0" rIns="0" tIns="0" bIns="0" anchor="t">
+            <a:spAutoFit/>
+          </a:bodyPr>
+          <a:lstStyle/>
+          <a:p>
+            <a:pPr algn="l">
+              <a:lnSpc>
+                <a:spcPct val="150000"/>
+              </a:lnSpc>
+            </a:pPr>
+            <a:r>
+              <a:rPr sz="1260" b="0" spc="36">
+                <a:solidFill>
+                  <a:srgbClr val="6E6E73"/>
+                </a:solidFill>
+                <a:latin typeface="Helvetica Neue"/>
+              </a:rPr>
+              <a:t>adapter</a:t>
+            </a:r>
+          </a:p>
+        </p:txBody>
+      </p:sp>
+      <p:sp>
+        <p:nvSpPr>
+          <p:cNvPr id="22" name="TextBox 21"/>
+          <p:cNvSpPr txBox="1"/>
+          <p:nvPr/>
+        </p:nvSpPr>
+        <p:spPr>
+          <a:xfrm>
+            <a:off x="4999533" y="2338387"/>
+            <a:ext cx="1142702" cy="363220"/>
+          </a:xfrm>
+          <a:prstGeom prst="rect">
+            <a:avLst/>
+          </a:prstGeom>
+          <a:noFill/>
+        </p:spPr>
+        <p:txBody>
+          <a:bodyPr wrap="none" lIns="0" rIns="0" tIns="0" bIns="0" anchor="t">
+            <a:spAutoFit/>
+          </a:bodyPr>
+          <a:lstStyle/>
+          <a:p>
+            <a:pPr algn="l">
+              <a:lnSpc>
+                <a:spcPct val="150000"/>
+              </a:lnSpc>
+            </a:pPr>
+            <a:r>
+              <a:rPr sz="1820" b="1" spc="-26">
+                <a:solidFill>
+                  <a:srgbClr val="1D1D1F"/>
+                </a:solidFill>
+                <a:latin typeface="Helvetica Neue"/>
+              </a:rPr>
+              <a:t>Zoom</a:t>
+            </a:r>
+          </a:p>
+        </p:txBody>
+      </p:sp>
+      <p:sp>
+        <p:nvSpPr>
+          <p:cNvPr id="23" name="TextBox 22"/>
+          <p:cNvSpPr txBox="1"/>
+          <p:nvPr/>
+        </p:nvSpPr>
+        <p:spPr>
+          <a:xfrm>
+            <a:off x="4999533" y="2592387"/>
+            <a:ext cx="1041102" cy="251460"/>
+          </a:xfrm>
+          <a:prstGeom prst="rect">
+            <a:avLst/>
+          </a:prstGeom>
+          <a:noFill/>
+        </p:spPr>
+        <p:txBody>
+          <a:bodyPr wrap="none" lIns="0" rIns="0" tIns="0" bIns="0" anchor="t">
+            <a:spAutoFit/>
+          </a:bodyPr>
+          <a:lstStyle/>
+          <a:p>
+            <a:pPr algn="l">
+              <a:lnSpc>
+                <a:spcPct val="150000"/>
+              </a:lnSpc>
+            </a:pPr>
+            <a:r>
+              <a:rPr sz="1260" b="0" spc="36">
+                <a:solidFill>
+                  <a:srgbClr val="6E6E73"/>
+                </a:solidFill>
+                <a:latin typeface="Helvetica Neue"/>
+              </a:rPr>
+              <a:t>adapter</a:t>
+            </a:r>
+          </a:p>
+        </p:txBody>
+      </p:sp>
+      <p:sp>
+        <p:nvSpPr>
+          <p:cNvPr id="24" name="TextBox 23"/>
+          <p:cNvSpPr txBox="1"/>
+          <p:nvPr/>
+        </p:nvSpPr>
+        <p:spPr>
+          <a:xfrm>
+            <a:off x="7948116" y="3362821"/>
+            <a:ext cx="855156" cy="388620"/>
+          </a:xfrm>
+          <a:prstGeom prst="rect">
+            <a:avLst/>
+          </a:prstGeom>
+          <a:noFill/>
+        </p:spPr>
+        <p:txBody>
+          <a:bodyPr wrap="none" lIns="0" rIns="0" tIns="0" bIns="0" anchor="t">
+            <a:spAutoFit/>
+          </a:bodyPr>
+          <a:lstStyle/>
+          <a:p>
+            <a:pPr algn="l">
+              <a:lnSpc>
+                <a:spcPct val="100000"/>
+              </a:lnSpc>
+            </a:pPr>
+            <a:r>
+              <a:rPr sz="2520" b="0">
+                <a:solidFill>
+                  <a:srgbClr val="C2C6D2"/>
+                </a:solidFill>
+                <a:latin typeface="Helvetica Neue"/>
+              </a:rPr>
+              <a:t>→</a:t>
+            </a:r>
+          </a:p>
+        </p:txBody>
+      </p:sp>
+      <p:sp>
+        <p:nvSpPr>
+          <p:cNvPr id="25" name="TextBox 24"/>
+          <p:cNvSpPr txBox="1"/>
+          <p:nvPr/>
+        </p:nvSpPr>
+        <p:spPr>
+          <a:xfrm>
+            <a:off x="8468717" y="1523305"/>
+            <a:ext cx="3469282" cy="209550"/>
+          </a:xfrm>
+          <a:prstGeom prst="rect">
+            <a:avLst/>
+          </a:prstGeom>
+          <a:noFill/>
+        </p:spPr>
+        <p:txBody>
+          <a:bodyPr wrap="none" lIns="0" rIns="0" tIns="0" bIns="0" anchor="t">
+            <a:spAutoFit/>
+          </a:bodyPr>
+          <a:lstStyle/>
+          <a:p>
+            <a:pPr algn="l">
+              <a:lnSpc>
+                <a:spcPct val="150000"/>
+              </a:lnSpc>
+            </a:pPr>
+            <a:r>
+              <a:rPr sz="1050" b="0" spc="300">
+                <a:solidFill>
+                  <a:srgbClr val="B25000"/>
+                </a:solidFill>
+                <a:latin typeface="Helvetica Neue"/>
+              </a:rPr>
+              <a:t>THEN</a:t>
+            </a:r>
+          </a:p>
+        </p:txBody>
+      </p:sp>
+      <p:sp>
+        <p:nvSpPr>
+          <p:cNvPr id="26" name="TextBox 25"/>
+          <p:cNvSpPr txBox="1"/>
+          <p:nvPr/>
+        </p:nvSpPr>
+        <p:spPr>
+          <a:xfrm>
+            <a:off x="8913217" y="1830685"/>
+            <a:ext cx="2641778" cy="363220"/>
+          </a:xfrm>
+          <a:prstGeom prst="rect">
+            <a:avLst/>
+          </a:prstGeom>
+          <a:noFill/>
+        </p:spPr>
+        <p:txBody>
+          <a:bodyPr wrap="none" lIns="0" rIns="0" tIns="0" bIns="0" anchor="t">
+            <a:spAutoFit/>
+          </a:bodyPr>
+          <a:lstStyle/>
+          <a:p>
+            <a:pPr algn="l">
+              <a:lnSpc>
+                <a:spcPct val="150000"/>
+              </a:lnSpc>
+            </a:pPr>
+            <a:r>
+              <a:rPr sz="1820" b="1" spc="-26">
+                <a:solidFill>
+                  <a:srgbClr val="1D1D1F"/>
+                </a:solidFill>
+                <a:latin typeface="Helvetica Neue"/>
+              </a:rPr>
+              <a:t>Microsoft Teams</a:t>
+            </a:r>
+          </a:p>
+        </p:txBody>
+      </p:sp>
+      <p:sp>
+        <p:nvSpPr>
+          <p:cNvPr id="27" name="TextBox 26"/>
+          <p:cNvSpPr txBox="1"/>
+          <p:nvPr/>
+        </p:nvSpPr>
+        <p:spPr>
+          <a:xfrm>
+            <a:off x="8913217" y="2084685"/>
+            <a:ext cx="2540178" cy="251460"/>
+          </a:xfrm>
+          <a:prstGeom prst="rect">
+            <a:avLst/>
+          </a:prstGeom>
+          <a:noFill/>
+        </p:spPr>
+        <p:txBody>
+          <a:bodyPr wrap="none" lIns="0" rIns="0" tIns="0" bIns="0" anchor="t">
+            <a:spAutoFit/>
+          </a:bodyPr>
+          <a:lstStyle/>
+          <a:p>
+            <a:pPr algn="l">
+              <a:lnSpc>
+                <a:spcPct val="150000"/>
+              </a:lnSpc>
+            </a:pPr>
+            <a:r>
+              <a:rPr sz="1260" b="0" spc="36">
+                <a:solidFill>
+                  <a:srgbClr val="6E6E73"/>
+                </a:solidFill>
+                <a:latin typeface="Helvetica Neue"/>
+              </a:rPr>
+              <a:t>enterprise add-on</a:t>
+            </a:r>
+          </a:p>
+        </p:txBody>
+      </p:sp>
+      <p:sp>
+        <p:nvSpPr>
+          <p:cNvPr id="28" name="TextBox 27"/>
+          <p:cNvSpPr txBox="1"/>
+          <p:nvPr/>
+        </p:nvSpPr>
+        <p:spPr>
+          <a:xfrm>
+            <a:off x="8913217" y="2338387"/>
+            <a:ext cx="3024782" cy="363220"/>
+          </a:xfrm>
+          <a:prstGeom prst="rect">
+            <a:avLst/>
+          </a:prstGeom>
+          <a:noFill/>
+        </p:spPr>
+        <p:txBody>
+          <a:bodyPr wrap="none" lIns="0" rIns="0" tIns="0" bIns="0" anchor="t">
+            <a:spAutoFit/>
+          </a:bodyPr>
+          <a:lstStyle/>
+          <a:p>
+            <a:pPr algn="l">
+              <a:lnSpc>
+                <a:spcPct val="150000"/>
+              </a:lnSpc>
+            </a:pPr>
+            <a:r>
+              <a:rPr sz="1820" b="1" spc="-26">
+                <a:solidFill>
+                  <a:srgbClr val="1D1D1F"/>
+                </a:solidFill>
+                <a:latin typeface="Helvetica Neue"/>
+              </a:rPr>
+              <a:t>Company rules</a:t>
+            </a:r>
+          </a:p>
+        </p:txBody>
+      </p:sp>
+      <p:sp>
+        <p:nvSpPr>
+          <p:cNvPr id="29" name="TextBox 28"/>
+          <p:cNvSpPr txBox="1"/>
+          <p:nvPr/>
+        </p:nvSpPr>
+        <p:spPr>
+          <a:xfrm>
+            <a:off x="8913217" y="2592387"/>
+            <a:ext cx="3024782" cy="251460"/>
+          </a:xfrm>
+          <a:prstGeom prst="rect">
+            <a:avLst/>
+          </a:prstGeom>
+          <a:noFill/>
+        </p:spPr>
+        <p:txBody>
+          <a:bodyPr wrap="none" lIns="0" rIns="0" tIns="0" bIns="0" anchor="t">
+            <a:spAutoFit/>
+          </a:bodyPr>
+          <a:lstStyle/>
+          <a:p>
+            <a:pPr algn="l">
+              <a:lnSpc>
+                <a:spcPct val="150000"/>
+              </a:lnSpc>
+            </a:pPr>
+            <a:r>
+              <a:rPr sz="1260" b="0" spc="36">
+                <a:solidFill>
+                  <a:srgbClr val="6E6E73"/>
+                </a:solidFill>
+                <a:latin typeface="Helvetica Neue"/>
+              </a:rPr>
+              <a:t>set once, enforced in every meeting</a:t>
+            </a:r>
+          </a:p>
+        </p:txBody>
+      </p:sp>
+      <p:sp>
+        <p:nvSpPr>
+          <p:cNvPr id="30" name="TextBox 29"/>
+          <p:cNvSpPr txBox="1"/>
+          <p:nvPr/>
+        </p:nvSpPr>
+        <p:spPr>
+          <a:xfrm>
+            <a:off x="8913217" y="2846089"/>
+            <a:ext cx="3024782" cy="363220"/>
+          </a:xfrm>
+          <a:prstGeom prst="rect">
+            <a:avLst/>
+          </a:prstGeom>
+          <a:noFill/>
+        </p:spPr>
+        <p:txBody>
+          <a:bodyPr wrap="none" lIns="0" rIns="0" tIns="0" bIns="0" anchor="t">
+            <a:spAutoFit/>
+          </a:bodyPr>
+          <a:lstStyle/>
+          <a:p>
+            <a:pPr algn="l">
+              <a:lnSpc>
+                <a:spcPct val="150000"/>
+              </a:lnSpc>
+            </a:pPr>
+            <a:r>
+              <a:rPr sz="1820" b="1" spc="-26">
+                <a:solidFill>
+                  <a:srgbClr val="1D1D1F"/>
+                </a:solidFill>
+                <a:latin typeface="Helvetica Neue"/>
+              </a:rPr>
+              <a:t>Hand-off plugin</a:t>
+            </a:r>
+          </a:p>
+        </p:txBody>
+      </p:sp>
+      <p:sp>
+        <p:nvSpPr>
+          <p:cNvPr id="31" name="TextBox 30"/>
+          <p:cNvSpPr txBox="1"/>
+          <p:nvPr/>
+        </p:nvSpPr>
+        <p:spPr>
+          <a:xfrm>
+            <a:off x="8913217" y="3100089"/>
+            <a:ext cx="2971530" cy="422909"/>
+          </a:xfrm>
+          <a:prstGeom prst="rect">
+            <a:avLst/>
+          </a:prstGeom>
+          <a:noFill/>
+        </p:spPr>
+        <p:txBody>
+          <a:bodyPr wrap="square" lIns="0" rIns="0" tIns="0" bIns="0" anchor="t">
+            <a:spAutoFit/>
+          </a:bodyPr>
+          <a:lstStyle/>
+          <a:p>
+            <a:pPr algn="l">
+              <a:lnSpc>
+                <a:spcPct val="150000"/>
+              </a:lnSpc>
+            </a:pPr>
+            <a:r>
+              <a:rPr sz="1260" b="0" spc="36">
+                <a:solidFill>
+                  <a:srgbClr val="6E6E73"/>
+                </a:solidFill>
+                <a:latin typeface="Helvetica Neue"/>
+              </a:rPr>
+              <a:t>transcript, decisions and open items into the team's own knowledge agent</a:t>
+            </a:r>
+          </a:p>
+        </p:txBody>
+      </p:sp>
+      <p:sp>
+        <p:nvSpPr>
+          <p:cNvPr id="32" name="TextBox 31"/>
+          <p:cNvSpPr txBox="1"/>
+          <p:nvPr/>
+        </p:nvSpPr>
+        <p:spPr>
+          <a:xfrm>
+            <a:off x="444500" y="5791894"/>
+            <a:ext cx="2520424" cy="284480"/>
+          </a:xfrm>
+          <a:prstGeom prst="rect">
+            <a:avLst/>
+          </a:prstGeom>
+          <a:noFill/>
+        </p:spPr>
+        <p:txBody>
+          <a:bodyPr wrap="none" lIns="0" rIns="0" tIns="0" bIns="0" anchor="t">
+            <a:spAutoFit/>
+          </a:bodyPr>
+          <a:lstStyle/>
+          <a:p>
+            <a:pPr algn="l">
+              <a:lnSpc>
+                <a:spcPct val="150000"/>
+              </a:lnSpc>
+            </a:pPr>
+            <a:r>
+              <a:rPr sz="1680" b="1" spc="-24">
+                <a:solidFill>
+                  <a:srgbClr val="0071E3"/>
+                </a:solidFill>
+                <a:latin typeface="Helvetica Neue"/>
+              </a:rPr>
+              <a:t>Time governance</a:t>
+            </a:r>
+          </a:p>
+        </p:txBody>
+      </p:sp>
+      <p:sp>
+        <p:nvSpPr>
+          <p:cNvPr id="33" name="TextBox 32"/>
+          <p:cNvSpPr txBox="1"/>
+          <p:nvPr/>
+        </p:nvSpPr>
+        <p:spPr>
+          <a:xfrm>
+            <a:off x="444500" y="6035079"/>
+            <a:ext cx="11493500" cy="422909"/>
+          </a:xfrm>
+          <a:prstGeom prst="rect">
+            <a:avLst/>
+          </a:prstGeom>
+          <a:noFill/>
+        </p:spPr>
+        <p:txBody>
+          <a:bodyPr wrap="square" lIns="0" rIns="0" tIns="0" bIns="0" anchor="t">
+            <a:spAutoFit/>
+          </a:bodyPr>
+          <a:lstStyle/>
+          <a:p>
+            <a:pPr algn="l">
+              <a:lnSpc>
+                <a:spcPct val="150000"/>
+              </a:lnSpc>
+            </a:pPr>
+            <a:r>
+              <a:rPr sz="1260" b="0" spc="-24">
+                <a:solidFill>
+                  <a:srgbClr val="6E6E73"/>
+                </a:solidFill>
+                <a:latin typeface="Helvetica Neue"/>
+              </a:rPr>
+              <a:t>Notes tell you what happened. Karen changes what happens — inside the hour. At enterprise scale the rules stop being per-meeting: no agenda, no booking, and how hard she chairs is set company-wide, not by whoever called the meeting. And what the meeting produced does not stop at the call: the transcript, the decisions and the open items are handed to whatever agent already keeps the company's knowledge.</a:t>
+            </a:r>
+          </a:p>
+        </p:txBody>
+      </p:sp>
     </p:spTree>
   </p:cSld>
   <p:clrMapOvr>

</xml_diff>